<commit_message>
Section1 (CAD) PPTX: rebuild hand-tuned to match current 7-slide HTML — embed real adoption-curve + Mahoney bar-chart SVGs, update 'What went wrong' (3 current points) and 'A paradigm shift' turn-grid, drop hidden evidence slide
</commit_message>
<xml_diff>
--- a/keynote-iwbi-2026/pptx/sections/IWBI2026_Trivedi_01_CAD.pptx
+++ b/keynote-iwbi-2026/pptx/sections/IWBI2026_Trivedi_01_CAD.pptx
@@ -3951,7 +3951,7 @@
         <p:spPr>
           <a:xfrm>
             <a:off x="0" y="0"/>
-            <a:ext cx="12191695" cy="38100"/>
+            <a:ext cx="5486400" cy="38100"/>
           </a:xfrm>
           <a:prstGeom prst="rect">
             <a:avLst/>
@@ -3994,8 +3994,8 @@
         </p:nvSpPr>
         <p:spPr>
           <a:xfrm>
-            <a:off x="777240" y="2642616"/>
-            <a:ext cx="5989320" cy="346456"/>
+            <a:off x="777240" y="658368"/>
+            <a:ext cx="10607040" cy="365760"/>
           </a:xfrm>
           <a:prstGeom prst="rect">
             <a:avLst/>
@@ -4003,63 +4003,33 @@
           <a:noFill/>
         </p:spPr>
         <p:txBody>
-          <a:bodyPr wrap="square" lIns="25400" rIns="25400" tIns="12700" bIns="12700">
-            <a:noAutofit/>
+          <a:bodyPr wrap="square" anchor="t" lIns="0" rIns="0" tIns="0" bIns="0">
+            <a:spAutoFit/>
           </a:bodyPr>
           <a:lstStyle/>
           <a:p>
             <a:pPr algn="l">
               <a:lnSpc>
-                <a:spcPct val="128000"/>
+                <a:spcPct val="100000"/>
               </a:lnSpc>
-              <a:spcAft>
-                <a:spcPts val="400"/>
-              </a:spcAft>
             </a:pPr>
             <a:r>
-              <a:rPr sz="1400" b="0">
-                <a:solidFill>
-                  <a:srgbClr val="9DA9B5"/>
-                </a:solidFill>
-                <a:latin typeface="Arial"/>
+              <a:rPr sz="1100" b="1" i="0">
+                <a:solidFill>
+                  <a:srgbClr val="E7AC51"/>
+                </a:solidFill>
+                <a:latin typeface="Consolas"/>
               </a:rPr>
-              <a:t>Era I · 1998 · Lesion</a:t>
-            </a:r>
-            <a:r>
-              <a:rPr sz="1400" b="0">
-                <a:solidFill>
-                  <a:srgbClr val="9DA9B5"/>
-                </a:solidFill>
-                <a:latin typeface="Arial"/>
+              <a:t>ERA I · 1998 · LESION</a:t>
+            </a:r>
+            <a:r>
+              <a:rPr sz="1100" b="0" i="0">
+                <a:solidFill>
+                  <a:srgbClr val="5C6975"/>
+                </a:solidFill>
+                <a:latin typeface="Consolas"/>
               </a:rPr>
-              <a:t>→</a:t>
-            </a:r>
-            <a:r>
-              <a:rPr sz="1400" b="0">
-                <a:solidFill>
-                  <a:srgbClr val="9DA9B5"/>
-                </a:solidFill>
-                <a:latin typeface="Arial"/>
-              </a:rPr>
-              <a:t>Image</a:t>
-            </a:r>
-            <a:r>
-              <a:rPr sz="1400" b="0">
-                <a:solidFill>
-                  <a:srgbClr val="9DA9B5"/>
-                </a:solidFill>
-                <a:latin typeface="Arial"/>
-              </a:rPr>
-              <a:t>→</a:t>
-            </a:r>
-            <a:r>
-              <a:rPr sz="1400" b="0">
-                <a:solidFill>
-                  <a:srgbClr val="9DA9B5"/>
-                </a:solidFill>
-                <a:latin typeface="Arial"/>
-              </a:rPr>
-              <a:t>Patient</a:t>
+              <a:t>    →    IMAGE    →    PATIENT</a:t>
             </a:r>
           </a:p>
         </p:txBody>
@@ -4072,8 +4042,8 @@
         </p:nvSpPr>
         <p:spPr>
           <a:xfrm>
-            <a:off x="777240" y="2989072"/>
-            <a:ext cx="5989320" cy="790447"/>
+            <a:off x="777240" y="2286000"/>
+            <a:ext cx="6766560" cy="1554480"/>
           </a:xfrm>
           <a:prstGeom prst="rect">
             <a:avLst/>
@@ -4081,21 +4051,18 @@
           <a:noFill/>
         </p:spPr>
         <p:txBody>
-          <a:bodyPr wrap="square" lIns="25400" rIns="25400" tIns="12700" bIns="12700">
-            <a:noAutofit/>
+          <a:bodyPr wrap="square" anchor="t" lIns="0" rIns="0" tIns="0" bIns="0">
+            <a:spAutoFit/>
           </a:bodyPr>
           <a:lstStyle/>
           <a:p>
             <a:pPr algn="l">
               <a:lnSpc>
-                <a:spcPct val="106000"/>
+                <a:spcPct val="100000"/>
               </a:lnSpc>
-              <a:spcAft>
-                <a:spcPts val="400"/>
-              </a:spcAft>
             </a:pPr>
             <a:r>
-              <a:rPr sz="4400" b="0">
+              <a:rPr sz="5000" b="1" i="0">
                 <a:solidFill>
                   <a:srgbClr val="ECEFF3"/>
                 </a:solidFill>
@@ -4104,7 +4071,7 @@
               <a:t>The year is </a:t>
             </a:r>
             <a:r>
-              <a:rPr sz="4400" b="0">
+              <a:rPr sz="5000" b="1" i="0">
                 <a:solidFill>
                   <a:srgbClr val="E7AC51"/>
                 </a:solidFill>
@@ -4123,8 +4090,8 @@
         </p:nvSpPr>
         <p:spPr>
           <a:xfrm>
-            <a:off x="777240" y="3779520"/>
-            <a:ext cx="5989320" cy="801623"/>
+            <a:off x="777240" y="3977639"/>
+            <a:ext cx="6583680" cy="2011680"/>
           </a:xfrm>
           <a:prstGeom prst="rect">
             <a:avLst/>
@@ -4132,21 +4099,18 @@
           <a:noFill/>
         </p:spPr>
         <p:txBody>
-          <a:bodyPr wrap="square" lIns="25400" rIns="25400" tIns="12700" bIns="12700">
-            <a:noAutofit/>
+          <a:bodyPr wrap="square" anchor="t" lIns="0" rIns="0" tIns="0" bIns="0">
+            <a:spAutoFit/>
           </a:bodyPr>
           <a:lstStyle/>
           <a:p>
             <a:pPr algn="l">
               <a:lnSpc>
-                <a:spcPct val="128000"/>
+                <a:spcPct val="130000"/>
               </a:lnSpc>
-              <a:spcAft>
-                <a:spcPts val="400"/>
-              </a:spcAft>
             </a:pPr>
             <a:r>
-              <a:rPr sz="1400" b="0">
+              <a:rPr sz="1800" b="0" i="0">
                 <a:solidFill>
                   <a:srgbClr val="9DA9B5"/>
                 </a:solidFill>
@@ -4165,14 +4129,14 @@
         </p:nvSpPr>
         <p:spPr>
           <a:xfrm>
-            <a:off x="6912864" y="1037844"/>
-            <a:ext cx="4782312" cy="4782312"/>
+            <a:off x="7726680" y="1554480"/>
+            <a:ext cx="3840480" cy="3840480"/>
           </a:xfrm>
           <a:prstGeom prst="roundRect">
             <a:avLst/>
           </a:prstGeom>
           <a:solidFill>
-            <a:srgbClr val="FFFFFF"/>
+            <a:srgbClr val="000000"/>
           </a:solidFill>
           <a:ln w="9525">
             <a:solidFill>
@@ -4205,7 +4169,7 @@
       </p:sp>
       <p:pic>
         <p:nvPicPr>
-          <p:cNvPr id="7" name="Picture 6" descr="i_a5f0143ecc.png"/>
+          <p:cNvPr id="7" name="Picture 6" descr="img_a5f0143ecc.png"/>
           <p:cNvPicPr>
             <a:picLocks noChangeAspect="1"/>
           </p:cNvPicPr>
@@ -4219,8 +4183,8 @@
         </p:blipFill>
         <p:spPr>
           <a:xfrm>
-            <a:off x="6995160" y="1120140"/>
-            <a:ext cx="4617720" cy="4617720"/>
+            <a:off x="7818120" y="1645920"/>
+            <a:ext cx="3657600" cy="3657600"/>
           </a:xfrm>
           <a:prstGeom prst="rect">
             <a:avLst/>
@@ -4262,7 +4226,7 @@
         <p:spPr>
           <a:xfrm>
             <a:off x="0" y="0"/>
-            <a:ext cx="12191695" cy="38100"/>
+            <a:ext cx="5486400" cy="38100"/>
           </a:xfrm>
           <a:prstGeom prst="rect">
             <a:avLst/>
@@ -4305,8 +4269,8 @@
         </p:nvSpPr>
         <p:spPr>
           <a:xfrm>
-            <a:off x="777240" y="411480"/>
-            <a:ext cx="8686800" cy="365760"/>
+            <a:off x="777240" y="502920"/>
+            <a:ext cx="5486400" cy="320040"/>
           </a:xfrm>
           <a:prstGeom prst="rect">
             <a:avLst/>
@@ -4314,21 +4278,18 @@
           <a:noFill/>
         </p:spPr>
         <p:txBody>
-          <a:bodyPr wrap="square" lIns="25400" rIns="25400" tIns="12700" bIns="12700">
-            <a:noAutofit/>
+          <a:bodyPr wrap="square" anchor="t" lIns="0" rIns="0" tIns="0" bIns="0">
+            <a:spAutoFit/>
           </a:bodyPr>
           <a:lstStyle/>
           <a:p>
             <a:pPr algn="l">
               <a:lnSpc>
-                <a:spcPct val="128000"/>
+                <a:spcPct val="100000"/>
               </a:lnSpc>
-              <a:spcAft>
-                <a:spcPts val="400"/>
-              </a:spcAft>
             </a:pPr>
             <a:r>
-              <a:rPr sz="1100" b="1">
+              <a:rPr sz="1100" b="1" i="0">
                 <a:solidFill>
                   <a:srgbClr val="E7AC51"/>
                 </a:solidFill>
@@ -4347,8 +4308,8 @@
         </p:nvSpPr>
         <p:spPr>
           <a:xfrm>
-            <a:off x="777240" y="2319020"/>
-            <a:ext cx="5989320" cy="1274064"/>
+            <a:off x="777240" y="1097280"/>
+            <a:ext cx="10607040" cy="1005840"/>
           </a:xfrm>
           <a:prstGeom prst="rect">
             <a:avLst/>
@@ -4356,21 +4317,18 @@
           <a:noFill/>
         </p:spPr>
         <p:txBody>
-          <a:bodyPr wrap="square" lIns="25400" rIns="25400" tIns="12700" bIns="12700">
-            <a:noAutofit/>
+          <a:bodyPr wrap="square" anchor="t" lIns="0" rIns="0" tIns="0" bIns="0">
+            <a:spAutoFit/>
           </a:bodyPr>
           <a:lstStyle/>
           <a:p>
             <a:pPr algn="l">
               <a:lnSpc>
-                <a:spcPct val="106000"/>
+                <a:spcPct val="105000"/>
               </a:lnSpc>
-              <a:spcAft>
-                <a:spcPts val="400"/>
-              </a:spcAft>
             </a:pPr>
             <a:r>
-              <a:rPr sz="2600" b="0">
+              <a:rPr sz="3000" b="1" i="0">
                 <a:solidFill>
                   <a:srgbClr val="ECEFF3"/>
                 </a:solidFill>
@@ -4379,7 +4337,7 @@
               <a:t>Within a decade, CAD was used on </a:t>
             </a:r>
             <a:r>
-              <a:rPr sz="2600" b="0">
+              <a:rPr sz="3000" b="1" i="0">
                 <a:solidFill>
                   <a:srgbClr val="E7AC51"/>
                 </a:solidFill>
@@ -4390,153 +4348,9 @@
           </a:p>
         </p:txBody>
       </p:sp>
-      <p:sp>
-        <p:nvSpPr>
-          <p:cNvPr id="5" name="TextBox 4"/>
-          <p:cNvSpPr txBox="1"/>
-          <p:nvPr/>
-        </p:nvSpPr>
-        <p:spPr>
-          <a:xfrm>
-            <a:off x="777240" y="3593084"/>
-            <a:ext cx="5989320" cy="346456"/>
-          </a:xfrm>
-          <a:prstGeom prst="rect">
-            <a:avLst/>
-          </a:prstGeom>
-          <a:noFill/>
-        </p:spPr>
-        <p:txBody>
-          <a:bodyPr wrap="square" lIns="25400" rIns="25400" tIns="12700" bIns="12700">
-            <a:noAutofit/>
-          </a:bodyPr>
-          <a:lstStyle/>
-          <a:p>
-            <a:pPr algn="l">
-              <a:lnSpc>
-                <a:spcPct val="128000"/>
-              </a:lnSpc>
-              <a:spcAft>
-                <a:spcPts val="400"/>
-              </a:spcAft>
-            </a:pPr>
-            <a:r>
-              <a:rPr sz="1400" b="0">
-                <a:solidFill>
-                  <a:srgbClr val="9DA9B5"/>
-                </a:solidFill>
-                <a:latin typeface="Arial"/>
-              </a:rPr>
-              <a:t> </a:t>
-            </a:r>
-            <a:r>
-              <a:rPr sz="1400" b="0">
-                <a:solidFill>
-                  <a:srgbClr val="9DA9B5"/>
-                </a:solidFill>
-                <a:latin typeface="Arial"/>
-              </a:rPr>
-              <a:t> </a:t>
-            </a:r>
-          </a:p>
-        </p:txBody>
-      </p:sp>
-      <p:sp>
-        <p:nvSpPr>
-          <p:cNvPr id="6" name="TextBox 5"/>
-          <p:cNvSpPr txBox="1"/>
-          <p:nvPr/>
-        </p:nvSpPr>
-        <p:spPr>
-          <a:xfrm>
-            <a:off x="777240" y="3939540"/>
-            <a:ext cx="5989320" cy="574040"/>
-          </a:xfrm>
-          <a:prstGeom prst="rect">
-            <a:avLst/>
-          </a:prstGeom>
-          <a:noFill/>
-        </p:spPr>
-        <p:txBody>
-          <a:bodyPr wrap="square" lIns="25400" rIns="25400" tIns="12700" bIns="12700">
-            <a:noAutofit/>
-          </a:bodyPr>
-          <a:lstStyle/>
-          <a:p>
-            <a:pPr algn="l">
-              <a:lnSpc>
-                <a:spcPct val="128000"/>
-              </a:lnSpc>
-              <a:spcAft>
-                <a:spcPts val="400"/>
-              </a:spcAft>
-            </a:pPr>
-            <a:r>
-              <a:rPr sz="1400" b="0">
-                <a:solidFill>
-                  <a:srgbClr val="9DA9B5"/>
-                </a:solidFill>
-                <a:latin typeface="Arial"/>
-              </a:rPr>
-              <a:t>A 2002 reimbursement code drove adoption — not evidence of benefit.</a:t>
-            </a:r>
-          </a:p>
-        </p:txBody>
-      </p:sp>
-      <p:sp>
-        <p:nvSpPr>
-          <p:cNvPr id="7" name="TextBox 6"/>
-          <p:cNvSpPr txBox="1"/>
-          <p:nvPr/>
-        </p:nvSpPr>
-        <p:spPr>
-          <a:xfrm>
-            <a:off x="777240" y="4513580"/>
-            <a:ext cx="5989320" cy="574040"/>
-          </a:xfrm>
-          <a:prstGeom prst="rect">
-            <a:avLst/>
-          </a:prstGeom>
-          <a:noFill/>
-        </p:spPr>
-        <p:txBody>
-          <a:bodyPr wrap="square" lIns="25400" rIns="25400" tIns="12700" bIns="12700">
-            <a:noAutofit/>
-          </a:bodyPr>
-          <a:lstStyle/>
-          <a:p>
-            <a:pPr algn="l">
-              <a:lnSpc>
-                <a:spcPct val="128000"/>
-              </a:lnSpc>
-              <a:spcAft>
-                <a:spcPts val="400"/>
-              </a:spcAft>
-            </a:pPr>
-            <a:r>
-              <a:rPr sz="1400" b="1">
-                <a:solidFill>
-                  <a:srgbClr val="ECEFF3"/>
-                </a:solidFill>
-                <a:latin typeface="Arial"/>
-              </a:rPr>
-              <a:t>The definitive study landed in 2015</a:t>
-            </a:r>
-            <a:r>
-              <a:rPr sz="1400" b="0">
-                <a:solidFill>
-                  <a:srgbClr val="9DA9B5"/>
-                </a:solidFill>
-                <a:latin typeface="Arial"/>
-              </a:rPr>
-              <a:t> — after CAD already ran on ~9 in 10 mammograms.</a:t>
-            </a:r>
-          </a:p>
-        </p:txBody>
-      </p:sp>
       <p:pic>
         <p:nvPicPr>
-          <p:cNvPr id="8" name="Picture 7" descr="s_ba5c8d2390.png"/>
+          <p:cNvPr id="5" name="Picture 4" descr="svg_ba5c8d2390.png"/>
           <p:cNvPicPr>
             <a:picLocks noChangeAspect="1"/>
           </p:cNvPicPr>
@@ -4550,14 +4364,71 @@
         </p:blipFill>
         <p:spPr>
           <a:xfrm>
-            <a:off x="6995160" y="2643987"/>
-            <a:ext cx="4617720" cy="1570024"/>
+            <a:off x="1374289" y="2240280"/>
+            <a:ext cx="9412941" cy="3200400"/>
           </a:xfrm>
           <a:prstGeom prst="rect">
             <a:avLst/>
           </a:prstGeom>
         </p:spPr>
       </p:pic>
+      <p:sp>
+        <p:nvSpPr>
+          <p:cNvPr id="6" name="TextBox 5"/>
+          <p:cNvSpPr txBox="1"/>
+          <p:nvPr/>
+        </p:nvSpPr>
+        <p:spPr>
+          <a:xfrm>
+            <a:off x="777240" y="5669280"/>
+            <a:ext cx="10607040" cy="731520"/>
+          </a:xfrm>
+          <a:prstGeom prst="rect">
+            <a:avLst/>
+          </a:prstGeom>
+          <a:noFill/>
+        </p:spPr>
+        <p:txBody>
+          <a:bodyPr wrap="square" anchor="t" lIns="0" rIns="0" tIns="0" bIns="0">
+            <a:spAutoFit/>
+          </a:bodyPr>
+          <a:lstStyle/>
+          <a:p>
+            <a:pPr algn="l">
+              <a:lnSpc>
+                <a:spcPct val="130000"/>
+              </a:lnSpc>
+            </a:pPr>
+            <a:r>
+              <a:rPr sz="1300" b="0" i="0">
+                <a:solidFill>
+                  <a:srgbClr val="9DA9B5"/>
+                </a:solidFill>
+                <a:latin typeface="Arial"/>
+              </a:rPr>
+              <a:t>A 2002 reimbursement code drove adoption — not evidence of benefit. </a:t>
+            </a:r>
+            <a:r>
+              <a:rPr sz="1300" b="1" i="0">
+                <a:solidFill>
+                  <a:srgbClr val="ECEFF3"/>
+                </a:solidFill>
+                <a:latin typeface="Arial"/>
+              </a:rPr>
+              <a:t>The definitive study landed in 2015</a:t>
+            </a:r>
+            <a:r>
+              <a:rPr sz="1300" b="0" i="0">
+                <a:solidFill>
+                  <a:srgbClr val="9DA9B5"/>
+                </a:solidFill>
+                <a:latin typeface="Arial"/>
+              </a:rPr>
+              <a:t> — after CAD already ran on ~9 in 10 mammograms.</a:t>
+            </a:r>
+          </a:p>
+        </p:txBody>
+      </p:sp>
     </p:spTree>
   </p:cSld>
   <p:clrMapOvr>
@@ -4593,7 +4464,7 @@
         <p:spPr>
           <a:xfrm>
             <a:off x="0" y="0"/>
-            <a:ext cx="12191695" cy="38100"/>
+            <a:ext cx="5486400" cy="38100"/>
           </a:xfrm>
           <a:prstGeom prst="rect">
             <a:avLst/>
@@ -4636,8 +4507,8 @@
         </p:nvSpPr>
         <p:spPr>
           <a:xfrm>
-            <a:off x="777240" y="411480"/>
-            <a:ext cx="8686800" cy="365760"/>
+            <a:off x="777240" y="502920"/>
+            <a:ext cx="5486400" cy="320040"/>
           </a:xfrm>
           <a:prstGeom prst="rect">
             <a:avLst/>
@@ -4645,21 +4516,18 @@
           <a:noFill/>
         </p:spPr>
         <p:txBody>
-          <a:bodyPr wrap="square" lIns="25400" rIns="25400" tIns="12700" bIns="12700">
-            <a:noAutofit/>
+          <a:bodyPr wrap="square" anchor="t" lIns="0" rIns="0" tIns="0" bIns="0">
+            <a:spAutoFit/>
           </a:bodyPr>
           <a:lstStyle/>
           <a:p>
             <a:pPr algn="l">
               <a:lnSpc>
-                <a:spcPct val="128000"/>
+                <a:spcPct val="100000"/>
               </a:lnSpc>
-              <a:spcAft>
-                <a:spcPts val="400"/>
-              </a:spcAft>
             </a:pPr>
             <a:r>
-              <a:rPr sz="1100" b="1">
+              <a:rPr sz="1100" b="1" i="0">
                 <a:solidFill>
                   <a:srgbClr val="E7AC51"/>
                 </a:solidFill>
@@ -4678,8 +4546,8 @@
         </p:nvSpPr>
         <p:spPr>
           <a:xfrm>
-            <a:off x="777240" y="1664969"/>
-            <a:ext cx="5989320" cy="1274064"/>
+            <a:off x="777240" y="1097280"/>
+            <a:ext cx="4937760" cy="1463040"/>
           </a:xfrm>
           <a:prstGeom prst="rect">
             <a:avLst/>
@@ -4687,21 +4555,18 @@
           <a:noFill/>
         </p:spPr>
         <p:txBody>
-          <a:bodyPr wrap="square" lIns="25400" rIns="25400" tIns="12700" bIns="12700">
-            <a:noAutofit/>
+          <a:bodyPr wrap="square" anchor="t" lIns="0" rIns="0" tIns="0" bIns="0">
+            <a:spAutoFit/>
           </a:bodyPr>
           <a:lstStyle/>
           <a:p>
             <a:pPr algn="l">
               <a:lnSpc>
-                <a:spcPct val="106000"/>
+                <a:spcPct val="112000"/>
               </a:lnSpc>
-              <a:spcAft>
-                <a:spcPts val="400"/>
-              </a:spcAft>
             </a:pPr>
             <a:r>
-              <a:rPr sz="2600" b="0">
+              <a:rPr sz="2400" b="1" i="0">
                 <a:solidFill>
                   <a:srgbClr val="ECEFF3"/>
                 </a:solidFill>
@@ -4710,7 +4575,7 @@
               <a:t>Conventional CAD put a </a:t>
             </a:r>
             <a:r>
-              <a:rPr sz="2600" b="0">
+              <a:rPr sz="2400" b="1" i="0">
                 <a:solidFill>
                   <a:srgbClr val="D9785B"/>
                 </a:solidFill>
@@ -4719,7 +4584,7 @@
               <a:t>false-positive mark</a:t>
             </a:r>
             <a:r>
-              <a:rPr sz="2600" b="0">
+              <a:rPr sz="2400" b="1" i="0">
                 <a:solidFill>
                   <a:srgbClr val="ECEFF3"/>
                 </a:solidFill>
@@ -4738,8 +4603,8 @@
         </p:nvSpPr>
         <p:spPr>
           <a:xfrm>
-            <a:off x="777240" y="2939033"/>
-            <a:ext cx="5989320" cy="525780"/>
+            <a:off x="777240" y="2880360"/>
+            <a:ext cx="4937760" cy="914400"/>
           </a:xfrm>
           <a:prstGeom prst="rect">
             <a:avLst/>
@@ -4747,21 +4612,18 @@
           <a:noFill/>
         </p:spPr>
         <p:txBody>
-          <a:bodyPr wrap="square" lIns="25400" rIns="25400" tIns="12700" bIns="12700">
-            <a:noAutofit/>
+          <a:bodyPr wrap="square" anchor="t" lIns="0" rIns="0" tIns="0" bIns="0">
+            <a:spAutoFit/>
           </a:bodyPr>
           <a:lstStyle/>
           <a:p>
             <a:pPr algn="l">
               <a:lnSpc>
-                <a:spcPct val="112000"/>
+                <a:spcPct val="100000"/>
               </a:lnSpc>
-              <a:spcAft>
-                <a:spcPts val="400"/>
-              </a:spcAft>
             </a:pPr>
             <a:r>
-              <a:rPr sz="3000" b="0">
+              <a:rPr sz="3800" b="1" i="0">
                 <a:solidFill>
                   <a:srgbClr val="E7AC51"/>
                 </a:solidFill>
@@ -4780,8 +4642,8 @@
         </p:nvSpPr>
         <p:spPr>
           <a:xfrm>
-            <a:off x="777240" y="3464814"/>
-            <a:ext cx="5989320" cy="346456"/>
+            <a:off x="777240" y="3639312"/>
+            <a:ext cx="4754880" cy="640080"/>
           </a:xfrm>
           <a:prstGeom prst="rect">
             <a:avLst/>
@@ -4789,30 +4651,27 @@
           <a:noFill/>
         </p:spPr>
         <p:txBody>
-          <a:bodyPr wrap="square" lIns="25400" rIns="25400" tIns="12700" bIns="12700">
-            <a:noAutofit/>
+          <a:bodyPr wrap="square" anchor="t" lIns="0" rIns="0" tIns="0" bIns="0">
+            <a:spAutoFit/>
           </a:bodyPr>
           <a:lstStyle/>
           <a:p>
             <a:pPr algn="l">
               <a:lnSpc>
-                <a:spcPct val="128000"/>
+                <a:spcPct val="125000"/>
               </a:lnSpc>
-              <a:spcAft>
-                <a:spcPts val="400"/>
-              </a:spcAft>
             </a:pPr>
             <a:r>
-              <a:rPr sz="1400" b="0">
-                <a:solidFill>
-                  <a:srgbClr val="9DA9B5"/>
+              <a:rPr sz="1200" b="0" i="0">
+                <a:solidFill>
+                  <a:srgbClr val="ECEFF3"/>
                 </a:solidFill>
                 <a:latin typeface="Arial"/>
               </a:rPr>
               <a:t>of normal mammograms had </a:t>
             </a:r>
             <a:r>
-              <a:rPr sz="1400" b="1">
+              <a:rPr sz="1200" b="1" i="0">
                 <a:solidFill>
                   <a:srgbClr val="D9785B"/>
                 </a:solidFill>
@@ -4831,8 +4690,8 @@
         </p:nvSpPr>
         <p:spPr>
           <a:xfrm>
-            <a:off x="777240" y="3811269"/>
-            <a:ext cx="5989320" cy="525780"/>
+            <a:off x="777240" y="4343400"/>
+            <a:ext cx="4937760" cy="914400"/>
           </a:xfrm>
           <a:prstGeom prst="rect">
             <a:avLst/>
@@ -4840,21 +4699,18 @@
           <a:noFill/>
         </p:spPr>
         <p:txBody>
-          <a:bodyPr wrap="square" lIns="25400" rIns="25400" tIns="12700" bIns="12700">
-            <a:noAutofit/>
+          <a:bodyPr wrap="square" anchor="t" lIns="0" rIns="0" tIns="0" bIns="0">
+            <a:spAutoFit/>
           </a:bodyPr>
           <a:lstStyle/>
           <a:p>
             <a:pPr algn="l">
               <a:lnSpc>
-                <a:spcPct val="112000"/>
+                <a:spcPct val="100000"/>
               </a:lnSpc>
-              <a:spcAft>
-                <a:spcPts val="400"/>
-              </a:spcAft>
             </a:pPr>
             <a:r>
-              <a:rPr sz="3000" b="0">
+              <a:rPr sz="3800" b="1" i="0">
                 <a:solidFill>
                   <a:srgbClr val="E7AC51"/>
                 </a:solidFill>
@@ -4873,8 +4729,8 @@
         </p:nvSpPr>
         <p:spPr>
           <a:xfrm>
-            <a:off x="777240" y="4337050"/>
-            <a:ext cx="5989320" cy="346456"/>
+            <a:off x="777240" y="5102352"/>
+            <a:ext cx="4754880" cy="731520"/>
           </a:xfrm>
           <a:prstGeom prst="rect">
             <a:avLst/>
@@ -4882,36 +4738,33 @@
           <a:noFill/>
         </p:spPr>
         <p:txBody>
-          <a:bodyPr wrap="square" lIns="25400" rIns="25400" tIns="12700" bIns="12700">
-            <a:noAutofit/>
+          <a:bodyPr wrap="square" anchor="t" lIns="0" rIns="0" tIns="0" bIns="0">
+            <a:spAutoFit/>
           </a:bodyPr>
           <a:lstStyle/>
           <a:p>
             <a:pPr algn="l">
               <a:lnSpc>
-                <a:spcPct val="128000"/>
+                <a:spcPct val="125000"/>
               </a:lnSpc>
-              <a:spcAft>
-                <a:spcPts val="400"/>
-              </a:spcAft>
             </a:pPr>
             <a:r>
-              <a:rPr sz="1400" b="1">
+              <a:rPr sz="1200" b="1" i="0">
                 <a:solidFill>
                   <a:srgbClr val="D9785B"/>
                 </a:solidFill>
                 <a:latin typeface="Arial"/>
               </a:rPr>
-              <a:t>false positives per image</a:t>
-            </a:r>
-            <a:r>
-              <a:rPr sz="1400" b="0">
-                <a:solidFill>
-                  <a:srgbClr val="9DA9B5"/>
+              <a:t>false positives </a:t>
+            </a:r>
+            <a:r>
+              <a:rPr sz="1200" b="0" i="0">
+                <a:solidFill>
+                  <a:srgbClr val="ECEFF3"/>
                 </a:solidFill>
                 <a:latin typeface="Arial"/>
               </a:rPr>
-              <a:t> — about 2–4 per 4-view case</a:t>
+              <a:t>per image — about 2–4 per 4-view case</a:t>
             </a:r>
           </a:p>
         </p:txBody>
@@ -4924,8 +4777,8 @@
         </p:nvSpPr>
         <p:spPr>
           <a:xfrm>
-            <a:off x="777240" y="4683506"/>
-            <a:ext cx="5989320" cy="256540"/>
+            <a:off x="777240" y="5943600"/>
+            <a:ext cx="5486400" cy="365760"/>
           </a:xfrm>
           <a:prstGeom prst="rect">
             <a:avLst/>
@@ -4933,21 +4786,18 @@
           <a:noFill/>
         </p:spPr>
         <p:txBody>
-          <a:bodyPr wrap="square" lIns="25400" rIns="25400" tIns="12700" bIns="12700">
-            <a:noAutofit/>
+          <a:bodyPr wrap="square" anchor="t" lIns="0" rIns="0" tIns="0" bIns="0">
+            <a:spAutoFit/>
           </a:bodyPr>
           <a:lstStyle/>
           <a:p>
             <a:pPr algn="l">
               <a:lnSpc>
-                <a:spcPct val="130000"/>
+                <a:spcPct val="100000"/>
               </a:lnSpc>
-              <a:spcAft>
-                <a:spcPts val="400"/>
-              </a:spcAft>
             </a:pPr>
             <a:r>
-              <a:rPr sz="1000" b="0">
+              <a:rPr sz="1000" b="0" i="0">
                 <a:solidFill>
                   <a:srgbClr val="5C6975"/>
                 </a:solidFill>
@@ -4958,60 +4808,9 @@
           </a:p>
         </p:txBody>
       </p:sp>
-      <p:sp>
-        <p:nvSpPr>
-          <p:cNvPr id="10" name="TextBox 9"/>
-          <p:cNvSpPr txBox="1"/>
-          <p:nvPr/>
-        </p:nvSpPr>
-        <p:spPr>
-          <a:xfrm>
-            <a:off x="777240" y="4940046"/>
-            <a:ext cx="5989320" cy="801623"/>
-          </a:xfrm>
-          <a:prstGeom prst="rect">
-            <a:avLst/>
-          </a:prstGeom>
-          <a:noFill/>
-        </p:spPr>
-        <p:txBody>
-          <a:bodyPr wrap="square" lIns="25400" rIns="25400" tIns="12700" bIns="12700">
-            <a:noAutofit/>
-          </a:bodyPr>
-          <a:lstStyle/>
-          <a:p>
-            <a:pPr algn="l">
-              <a:lnSpc>
-                <a:spcPct val="128000"/>
-              </a:lnSpc>
-              <a:spcAft>
-                <a:spcPts val="400"/>
-              </a:spcAft>
-            </a:pPr>
-            <a:r>
-              <a:rPr sz="1400" b="0">
-                <a:solidFill>
-                  <a:srgbClr val="9DA9B5"/>
-                </a:solidFill>
-                <a:latin typeface="Arial"/>
-              </a:rPr>
-              <a:t>~2–3 false marks on a normal case; more on non-dense breasts. </a:t>
-            </a:r>
-            <a:r>
-              <a:rPr sz="1400" b="0">
-                <a:solidFill>
-                  <a:srgbClr val="9DA9B5"/>
-                </a:solidFill>
-                <a:latin typeface="Arial"/>
-              </a:rPr>
-              <a:t>Mahoney &amp; Meganathan, J Digit Imaging 2011 (Table 4) · PMC3180536.</a:t>
-            </a:r>
-          </a:p>
-        </p:txBody>
-      </p:sp>
       <p:pic>
         <p:nvPicPr>
-          <p:cNvPr id="11" name="Picture 10" descr="s_94f6a22e3f.png"/>
+          <p:cNvPr id="10" name="Picture 9" descr="svg_94f6a22e3f.png"/>
           <p:cNvPicPr>
             <a:picLocks noChangeAspect="1"/>
           </p:cNvPicPr>
@@ -5025,14 +4824,53 @@
         </p:blipFill>
         <p:spPr>
           <a:xfrm>
-            <a:off x="6995160" y="1910013"/>
-            <a:ext cx="4617720" cy="3037973"/>
+            <a:off x="6126480" y="1487103"/>
+            <a:ext cx="5486400" cy="3609473"/>
           </a:xfrm>
           <a:prstGeom prst="rect">
             <a:avLst/>
           </a:prstGeom>
         </p:spPr>
       </p:pic>
+      <p:sp>
+        <p:nvSpPr>
+          <p:cNvPr id="11" name="TextBox 10"/>
+          <p:cNvSpPr txBox="1"/>
+          <p:nvPr/>
+        </p:nvSpPr>
+        <p:spPr>
+          <a:xfrm>
+            <a:off x="6126480" y="5440680"/>
+            <a:ext cx="5486400" cy="731520"/>
+          </a:xfrm>
+          <a:prstGeom prst="rect">
+            <a:avLst/>
+          </a:prstGeom>
+          <a:noFill/>
+        </p:spPr>
+        <p:txBody>
+          <a:bodyPr wrap="square" anchor="t" lIns="0" rIns="0" tIns="0" bIns="0">
+            <a:spAutoFit/>
+          </a:bodyPr>
+          <a:lstStyle/>
+          <a:p>
+            <a:pPr algn="ctr">
+              <a:lnSpc>
+                <a:spcPct val="130000"/>
+              </a:lnSpc>
+            </a:pPr>
+            <a:r>
+              <a:rPr sz="900" b="0" i="0">
+                <a:solidFill>
+                  <a:srgbClr val="5C6975"/>
+                </a:solidFill>
+                <a:latin typeface="Consolas"/>
+              </a:rPr>
+              <a:t>Mean false-positive marks per case · ImageChecker v7.2 — Mahoney &amp; Meganathan, J Digit Imaging 2011 (Table 4) · PMC3180536.</a:t>
+            </a:r>
+          </a:p>
+        </p:txBody>
+      </p:sp>
     </p:spTree>
   </p:cSld>
   <p:clrMapOvr>
@@ -5068,7 +4906,7 @@
         <p:spPr>
           <a:xfrm>
             <a:off x="0" y="0"/>
-            <a:ext cx="12191695" cy="38100"/>
+            <a:ext cx="5486400" cy="38100"/>
           </a:xfrm>
           <a:prstGeom prst="rect">
             <a:avLst/>
@@ -5111,8 +4949,8 @@
         </p:nvSpPr>
         <p:spPr>
           <a:xfrm>
-            <a:off x="777240" y="411480"/>
-            <a:ext cx="8686800" cy="365760"/>
+            <a:off x="777240" y="502920"/>
+            <a:ext cx="5486400" cy="320040"/>
           </a:xfrm>
           <a:prstGeom prst="rect">
             <a:avLst/>
@@ -5120,21 +4958,18 @@
           <a:noFill/>
         </p:spPr>
         <p:txBody>
-          <a:bodyPr wrap="square" lIns="25400" rIns="25400" tIns="12700" bIns="12700">
-            <a:noAutofit/>
+          <a:bodyPr wrap="square" anchor="t" lIns="0" rIns="0" tIns="0" bIns="0">
+            <a:spAutoFit/>
           </a:bodyPr>
           <a:lstStyle/>
           <a:p>
             <a:pPr algn="l">
               <a:lnSpc>
-                <a:spcPct val="128000"/>
+                <a:spcPct val="100000"/>
               </a:lnSpc>
-              <a:spcAft>
-                <a:spcPts val="400"/>
-              </a:spcAft>
             </a:pPr>
             <a:r>
-              <a:rPr sz="1100" b="1">
+              <a:rPr sz="1100" b="1" i="0">
                 <a:solidFill>
                   <a:srgbClr val="E7AC51"/>
                 </a:solidFill>
@@ -5153,8 +4988,8 @@
         </p:nvSpPr>
         <p:spPr>
           <a:xfrm>
-            <a:off x="777240" y="2595118"/>
-            <a:ext cx="10607040" cy="346456"/>
+            <a:off x="1280160" y="2011680"/>
+            <a:ext cx="4572000" cy="1280160"/>
           </a:xfrm>
           <a:prstGeom prst="rect">
             <a:avLst/>
@@ -5162,36 +4997,33 @@
           <a:noFill/>
         </p:spPr>
         <p:txBody>
-          <a:bodyPr wrap="square" lIns="25400" rIns="25400" tIns="12700" bIns="12700">
-            <a:noAutofit/>
+          <a:bodyPr wrap="square" anchor="t" lIns="0" rIns="0" tIns="0" bIns="0">
+            <a:spAutoFit/>
           </a:bodyPr>
           <a:lstStyle/>
           <a:p>
             <a:pPr algn="l">
               <a:lnSpc>
-                <a:spcPct val="128000"/>
+                <a:spcPct val="100000"/>
               </a:lnSpc>
-              <a:spcAft>
-                <a:spcPts val="400"/>
-              </a:spcAft>
             </a:pPr>
             <a:r>
-              <a:rPr sz="1400" b="0">
-                <a:solidFill>
-                  <a:srgbClr val="9DA9B5"/>
+              <a:rPr sz="6600" b="1" i="0">
+                <a:solidFill>
+                  <a:srgbClr val="E7AC51"/>
                 </a:solidFill>
                 <a:latin typeface="Arial"/>
               </a:rPr>
               <a:t>$400M</a:t>
             </a:r>
             <a:r>
-              <a:rPr sz="1400" b="0">
+              <a:rPr sz="2600" b="0" i="0">
                 <a:solidFill>
                   <a:srgbClr val="9DA9B5"/>
                 </a:solidFill>
                 <a:latin typeface="Arial"/>
               </a:rPr>
-              <a:t>/yr</a:t>
+              <a:t> /yr</a:t>
             </a:r>
           </a:p>
         </p:txBody>
@@ -5204,8 +5036,8 @@
         </p:nvSpPr>
         <p:spPr>
           <a:xfrm>
-            <a:off x="777240" y="2941574"/>
-            <a:ext cx="10607040" cy="346456"/>
+            <a:off x="1280160" y="3429000"/>
+            <a:ext cx="4206240" cy="822960"/>
           </a:xfrm>
           <a:prstGeom prst="rect">
             <a:avLst/>
@@ -5213,25 +5045,22 @@
           <a:noFill/>
         </p:spPr>
         <p:txBody>
-          <a:bodyPr wrap="square" lIns="25400" rIns="25400" tIns="12700" bIns="12700">
-            <a:noAutofit/>
+          <a:bodyPr wrap="square" anchor="t" lIns="0" rIns="0" tIns="0" bIns="0">
+            <a:spAutoFit/>
           </a:bodyPr>
           <a:lstStyle/>
           <a:p>
             <a:pPr algn="l">
               <a:lnSpc>
-                <a:spcPct val="128000"/>
+                <a:spcPct val="130000"/>
               </a:lnSpc>
-              <a:spcAft>
-                <a:spcPts val="400"/>
-              </a:spcAft>
             </a:pPr>
             <a:r>
-              <a:rPr sz="1400" b="0">
-                <a:solidFill>
-                  <a:srgbClr val="9DA9B5"/>
-                </a:solidFill>
-                <a:latin typeface="Arial"/>
+              <a:rPr sz="1200" b="0" i="0">
+                <a:solidFill>
+                  <a:srgbClr val="ECEFF3"/>
+                </a:solidFill>
+                <a:latin typeface="Consolas"/>
               </a:rPr>
               <a:t>U.S. spend ≈ $1 of every $10,000 in health care</a:t>
             </a:r>
@@ -5246,8 +5075,8 @@
         </p:nvSpPr>
         <p:spPr>
           <a:xfrm>
-            <a:off x="777240" y="3288030"/>
-            <a:ext cx="10607040" cy="346456"/>
+            <a:off x="6492240" y="2011680"/>
+            <a:ext cx="4754880" cy="1280160"/>
           </a:xfrm>
           <a:prstGeom prst="rect">
             <a:avLst/>
@@ -5255,32 +5084,29 @@
           <a:noFill/>
         </p:spPr>
         <p:txBody>
-          <a:bodyPr wrap="square" lIns="25400" rIns="25400" tIns="12700" bIns="12700">
-            <a:noAutofit/>
+          <a:bodyPr wrap="square" anchor="t" lIns="0" rIns="0" tIns="0" bIns="0">
+            <a:spAutoFit/>
           </a:bodyPr>
           <a:lstStyle/>
           <a:p>
             <a:pPr algn="l">
               <a:lnSpc>
-                <a:spcPct val="128000"/>
+                <a:spcPct val="100000"/>
               </a:lnSpc>
-              <a:spcAft>
-                <a:spcPts val="400"/>
-              </a:spcAft>
             </a:pPr>
             <a:r>
-              <a:rPr sz="1400" b="0">
-                <a:solidFill>
-                  <a:srgbClr val="9DA9B5"/>
+              <a:rPr sz="6600" b="1" i="0">
+                <a:solidFill>
+                  <a:srgbClr val="E7AC51"/>
                 </a:solidFill>
                 <a:latin typeface="Arial"/>
               </a:rPr>
               <a:t>−47%</a:t>
             </a:r>
             <a:r>
-              <a:rPr sz="1400" b="0">
-                <a:solidFill>
-                  <a:srgbClr val="9DA9B5"/>
+              <a:rPr sz="2200" b="0" i="0">
+                <a:solidFill>
+                  <a:srgbClr val="5C6975"/>
                 </a:solidFill>
                 <a:latin typeface="Arial"/>
               </a:rPr>
@@ -5297,8 +5123,8 @@
         </p:nvSpPr>
         <p:spPr>
           <a:xfrm>
-            <a:off x="777240" y="3634486"/>
-            <a:ext cx="10607040" cy="346456"/>
+            <a:off x="6492240" y="3429000"/>
+            <a:ext cx="4754880" cy="1005840"/>
           </a:xfrm>
           <a:prstGeom prst="rect">
             <a:avLst/>
@@ -5306,25 +5132,22 @@
           <a:noFill/>
         </p:spPr>
         <p:txBody>
-          <a:bodyPr wrap="square" lIns="25400" rIns="25400" tIns="12700" bIns="12700">
-            <a:noAutofit/>
+          <a:bodyPr wrap="square" anchor="t" lIns="0" rIns="0" tIns="0" bIns="0">
+            <a:spAutoFit/>
           </a:bodyPr>
           <a:lstStyle/>
           <a:p>
             <a:pPr algn="l">
               <a:lnSpc>
-                <a:spcPct val="128000"/>
+                <a:spcPct val="130000"/>
               </a:lnSpc>
-              <a:spcAft>
-                <a:spcPts val="400"/>
-              </a:spcAft>
             </a:pPr>
             <a:r>
-              <a:rPr sz="1400" b="0">
-                <a:solidFill>
-                  <a:srgbClr val="9DA9B5"/>
-                </a:solidFill>
-                <a:latin typeface="Arial"/>
+              <a:rPr sz="1200" b="0" i="0">
+                <a:solidFill>
+                  <a:srgbClr val="ECEFF3"/>
+                </a:solidFill>
+                <a:latin typeface="Consolas"/>
               </a:rPr>
               <a:t>odds of detecting a malignant lesion — CAD on vs off, same readers (OR 0.53)</a:t>
             </a:r>
@@ -5339,8 +5162,8 @@
         </p:nvSpPr>
         <p:spPr>
           <a:xfrm>
-            <a:off x="777240" y="3980942"/>
-            <a:ext cx="10607040" cy="574040"/>
+            <a:off x="1280160" y="4663440"/>
+            <a:ext cx="9692640" cy="731520"/>
           </a:xfrm>
           <a:prstGeom prst="rect">
             <a:avLst/>
@@ -5348,21 +5171,18 @@
           <a:noFill/>
         </p:spPr>
         <p:txBody>
-          <a:bodyPr wrap="square" lIns="25400" rIns="25400" tIns="12700" bIns="12700">
-            <a:noAutofit/>
+          <a:bodyPr wrap="square" anchor="t" lIns="0" rIns="0" tIns="0" bIns="0">
+            <a:spAutoFit/>
           </a:bodyPr>
           <a:lstStyle/>
           <a:p>
             <a:pPr algn="l">
               <a:lnSpc>
-                <a:spcPct val="128000"/>
+                <a:spcPct val="130000"/>
               </a:lnSpc>
-              <a:spcAft>
-                <a:spcPts val="400"/>
-              </a:spcAft>
             </a:pPr>
             <a:r>
-              <a:rPr sz="1400" b="0">
+              <a:rPr sz="1800" b="0" i="0">
                 <a:solidFill>
                   <a:srgbClr val="9DA9B5"/>
                 </a:solidFill>
@@ -5381,8 +5201,8 @@
         </p:nvSpPr>
         <p:spPr>
           <a:xfrm>
-            <a:off x="777240" y="4554982"/>
-            <a:ext cx="10607040" cy="256540"/>
+            <a:off x="1280160" y="5577840"/>
+            <a:ext cx="9692640" cy="365760"/>
           </a:xfrm>
           <a:prstGeom prst="rect">
             <a:avLst/>
@@ -5390,21 +5210,18 @@
           <a:noFill/>
         </p:spPr>
         <p:txBody>
-          <a:bodyPr wrap="square" lIns="25400" rIns="25400" tIns="12700" bIns="12700">
-            <a:noAutofit/>
+          <a:bodyPr wrap="square" anchor="t" lIns="0" rIns="0" tIns="0" bIns="0">
+            <a:spAutoFit/>
           </a:bodyPr>
           <a:lstStyle/>
           <a:p>
             <a:pPr algn="l">
               <a:lnSpc>
-                <a:spcPct val="130000"/>
+                <a:spcPct val="100000"/>
               </a:lnSpc>
-              <a:spcAft>
-                <a:spcPts val="400"/>
-              </a:spcAft>
             </a:pPr>
             <a:r>
-              <a:rPr sz="1000" b="0">
+              <a:rPr sz="1000" b="0" i="0">
                 <a:solidFill>
                   <a:srgbClr val="5C6975"/>
                 </a:solidFill>
@@ -5450,7 +5267,7 @@
         <p:spPr>
           <a:xfrm>
             <a:off x="0" y="0"/>
-            <a:ext cx="12191695" cy="38100"/>
+            <a:ext cx="5486400" cy="38100"/>
           </a:xfrm>
           <a:prstGeom prst="rect">
             <a:avLst/>
@@ -5493,8 +5310,8 @@
         </p:nvSpPr>
         <p:spPr>
           <a:xfrm>
-            <a:off x="777240" y="411480"/>
-            <a:ext cx="8686800" cy="365760"/>
+            <a:off x="777240" y="502920"/>
+            <a:ext cx="5486400" cy="320040"/>
           </a:xfrm>
           <a:prstGeom prst="rect">
             <a:avLst/>
@@ -5502,21 +5319,18 @@
           <a:noFill/>
         </p:spPr>
         <p:txBody>
-          <a:bodyPr wrap="square" lIns="25400" rIns="25400" tIns="12700" bIns="12700">
-            <a:noAutofit/>
+          <a:bodyPr wrap="square" anchor="t" lIns="0" rIns="0" tIns="0" bIns="0">
+            <a:spAutoFit/>
           </a:bodyPr>
           <a:lstStyle/>
           <a:p>
             <a:pPr algn="l">
               <a:lnSpc>
-                <a:spcPct val="128000"/>
+                <a:spcPct val="100000"/>
               </a:lnSpc>
-              <a:spcAft>
-                <a:spcPts val="400"/>
-              </a:spcAft>
             </a:pPr>
             <a:r>
-              <a:rPr sz="1100" b="1">
+              <a:rPr sz="1100" b="1" i="0">
                 <a:solidFill>
                   <a:srgbClr val="E7AC51"/>
                 </a:solidFill>
@@ -5535,8 +5349,8 @@
         </p:nvSpPr>
         <p:spPr>
           <a:xfrm>
-            <a:off x="777240" y="2248662"/>
-            <a:ext cx="10607040" cy="574040"/>
+            <a:off x="777240" y="1371600"/>
+            <a:ext cx="6949440" cy="3108960"/>
           </a:xfrm>
           <a:prstGeom prst="rect">
             <a:avLst/>
@@ -5544,27 +5358,24 @@
           <a:noFill/>
         </p:spPr>
         <p:txBody>
-          <a:bodyPr wrap="square" lIns="25400" rIns="25400" tIns="12700" bIns="12700">
-            <a:noAutofit/>
+          <a:bodyPr wrap="square" anchor="t" lIns="0" rIns="0" tIns="0" bIns="0">
+            <a:spAutoFit/>
           </a:bodyPr>
           <a:lstStyle/>
           <a:p>
             <a:pPr algn="l">
               <a:lnSpc>
-                <a:spcPct val="128000"/>
+                <a:spcPct val="125000"/>
               </a:lnSpc>
-              <a:spcAft>
-                <a:spcPts val="400"/>
-              </a:spcAft>
             </a:pPr>
             <a:r>
-              <a:rPr sz="1400" b="0">
-                <a:solidFill>
-                  <a:srgbClr val="9DA9B5"/>
+              <a:rPr sz="2500" b="1" i="0">
+                <a:solidFill>
+                  <a:srgbClr val="ECEFF3"/>
                 </a:solidFill>
                 <a:latin typeface="Arial"/>
               </a:rPr>
-              <a:t>Computer-aided detection does not improve diagnostic accuracy of mammography. These results suggest that insurers pay more for CAD with no established benefit to women.</a:t>
+              <a:t>“Computer-aided detection does not improve diagnostic accuracy of mammography. These results suggest that insurers pay more for CAD with no established benefit to women.”</a:t>
             </a:r>
           </a:p>
         </p:txBody>
@@ -5577,8 +5388,8 @@
         </p:nvSpPr>
         <p:spPr>
           <a:xfrm>
-            <a:off x="777240" y="2822702"/>
-            <a:ext cx="10607040" cy="256540"/>
+            <a:off x="777240" y="4800600"/>
+            <a:ext cx="6949440" cy="457200"/>
           </a:xfrm>
           <a:prstGeom prst="rect">
             <a:avLst/>
@@ -5586,23 +5397,20 @@
           <a:noFill/>
         </p:spPr>
         <p:txBody>
-          <a:bodyPr wrap="square" lIns="25400" rIns="25400" tIns="12700" bIns="12700">
-            <a:noAutofit/>
+          <a:bodyPr wrap="square" anchor="t" lIns="0" rIns="0" tIns="0" bIns="0">
+            <a:spAutoFit/>
           </a:bodyPr>
           <a:lstStyle/>
           <a:p>
             <a:pPr algn="l">
               <a:lnSpc>
-                <a:spcPct val="130000"/>
+                <a:spcPct val="100000"/>
               </a:lnSpc>
-              <a:spcAft>
-                <a:spcPts val="400"/>
-              </a:spcAft>
             </a:pPr>
             <a:r>
-              <a:rPr sz="1000" b="0">
-                <a:solidFill>
-                  <a:srgbClr val="5C6975"/>
+              <a:rPr sz="1300" b="0" i="0">
+                <a:solidFill>
+                  <a:srgbClr val="E7AC51"/>
                 </a:solidFill>
                 <a:latin typeface="Consolas"/>
               </a:rPr>
@@ -5619,8 +5427,8 @@
         </p:nvSpPr>
         <p:spPr>
           <a:xfrm>
-            <a:off x="777240" y="3079241"/>
-            <a:ext cx="10607040" cy="346456"/>
+            <a:off x="8229600" y="1645920"/>
+            <a:ext cx="3200400" cy="502920"/>
           </a:xfrm>
           <a:prstGeom prst="rect">
             <a:avLst/>
@@ -5628,45 +5436,24 @@
           <a:noFill/>
         </p:spPr>
         <p:txBody>
-          <a:bodyPr wrap="square" lIns="25400" rIns="25400" tIns="12700" bIns="12700">
-            <a:noAutofit/>
+          <a:bodyPr wrap="square" anchor="t" lIns="0" rIns="0" tIns="0" bIns="0">
+            <a:spAutoFit/>
           </a:bodyPr>
           <a:lstStyle/>
           <a:p>
             <a:pPr algn="l">
               <a:lnSpc>
-                <a:spcPct val="128000"/>
+                <a:spcPct val="100000"/>
               </a:lnSpc>
-              <a:spcAft>
-                <a:spcPts val="400"/>
-              </a:spcAft>
             </a:pPr>
             <a:r>
-              <a:rPr sz="1400" b="0">
-                <a:solidFill>
-                  <a:srgbClr val="9DA9B5"/>
+              <a:rPr sz="1800" b="1" i="0">
+                <a:solidFill>
+                  <a:srgbClr val="ECEFF3"/>
                 </a:solidFill>
                 <a:latin typeface="Arial"/>
               </a:rPr>
-              <a:t>85.3% </a:t>
-            </a:r>
-            <a:r>
-              <a:rPr sz="1400" b="0">
-                <a:solidFill>
-                  <a:srgbClr val="9DA9B5"/>
-                </a:solidFill>
-                <a:latin typeface="Arial"/>
-              </a:rPr>
-              <a:t>vs</a:t>
-            </a:r>
-            <a:r>
-              <a:rPr sz="1400" b="0">
-                <a:solidFill>
-                  <a:srgbClr val="9DA9B5"/>
-                </a:solidFill>
-                <a:latin typeface="Arial"/>
-              </a:rPr>
-              <a:t> 87.3%</a:t>
+              <a:t>85.3% vs 87.3%</a:t>
             </a:r>
           </a:p>
         </p:txBody>
@@ -5679,8 +5466,8 @@
         </p:nvSpPr>
         <p:spPr>
           <a:xfrm>
-            <a:off x="777240" y="3425698"/>
-            <a:ext cx="10607040" cy="346456"/>
+            <a:off x="8229600" y="2103120"/>
+            <a:ext cx="3200400" cy="548640"/>
           </a:xfrm>
           <a:prstGeom prst="rect">
             <a:avLst/>
@@ -5688,25 +5475,22 @@
           <a:noFill/>
         </p:spPr>
         <p:txBody>
-          <a:bodyPr wrap="square" lIns="25400" rIns="25400" tIns="12700" bIns="12700">
-            <a:noAutofit/>
+          <a:bodyPr wrap="square" anchor="t" lIns="0" rIns="0" tIns="0" bIns="0">
+            <a:spAutoFit/>
           </a:bodyPr>
           <a:lstStyle/>
           <a:p>
             <a:pPr algn="l">
               <a:lnSpc>
-                <a:spcPct val="128000"/>
+                <a:spcPct val="115000"/>
               </a:lnSpc>
-              <a:spcAft>
-                <a:spcPts val="400"/>
-              </a:spcAft>
             </a:pPr>
             <a:r>
-              <a:rPr sz="1400" b="0">
-                <a:solidFill>
-                  <a:srgbClr val="9DA9B5"/>
-                </a:solidFill>
-                <a:latin typeface="Arial"/>
+              <a:rPr sz="1050" b="0" i="0">
+                <a:solidFill>
+                  <a:srgbClr val="5C6975"/>
+                </a:solidFill>
+                <a:latin typeface="Consolas"/>
               </a:rPr>
               <a:t>sensitivity — with vs without CAD</a:t>
             </a:r>
@@ -5721,8 +5505,8 @@
         </p:nvSpPr>
         <p:spPr>
           <a:xfrm>
-            <a:off x="777240" y="3772154"/>
-            <a:ext cx="10607040" cy="346456"/>
+            <a:off x="8229600" y="2880360"/>
+            <a:ext cx="3200400" cy="502920"/>
           </a:xfrm>
           <a:prstGeom prst="rect">
             <a:avLst/>
@@ -5730,36 +5514,24 @@
           <a:noFill/>
         </p:spPr>
         <p:txBody>
-          <a:bodyPr wrap="square" lIns="25400" rIns="25400" tIns="12700" bIns="12700">
-            <a:noAutofit/>
+          <a:bodyPr wrap="square" anchor="t" lIns="0" rIns="0" tIns="0" bIns="0">
+            <a:spAutoFit/>
           </a:bodyPr>
           <a:lstStyle/>
           <a:p>
             <a:pPr algn="l">
               <a:lnSpc>
-                <a:spcPct val="128000"/>
+                <a:spcPct val="100000"/>
               </a:lnSpc>
-              <a:spcAft>
-                <a:spcPts val="400"/>
-              </a:spcAft>
             </a:pPr>
             <a:r>
-              <a:rPr sz="1400" b="0">
-                <a:solidFill>
-                  <a:srgbClr val="9DA9B5"/>
+              <a:rPr sz="1800" b="1" i="0">
+                <a:solidFill>
+                  <a:srgbClr val="ECEFF3"/>
                 </a:solidFill>
                 <a:latin typeface="Arial"/>
               </a:rPr>
-              <a:t>4.1 = 4.1</a:t>
-            </a:r>
-            <a:r>
-              <a:rPr sz="1400" b="0">
-                <a:solidFill>
-                  <a:srgbClr val="9DA9B5"/>
-                </a:solidFill>
-                <a:latin typeface="Arial"/>
-              </a:rPr>
-              <a:t> /1,000</a:t>
+              <a:t>4.1 = 4.1 /1,000</a:t>
             </a:r>
           </a:p>
         </p:txBody>
@@ -5772,8 +5544,8 @@
         </p:nvSpPr>
         <p:spPr>
           <a:xfrm>
-            <a:off x="777240" y="4118610"/>
-            <a:ext cx="10607040" cy="346456"/>
+            <a:off x="8229600" y="3337560"/>
+            <a:ext cx="3200400" cy="548640"/>
           </a:xfrm>
           <a:prstGeom prst="rect">
             <a:avLst/>
@@ -5781,25 +5553,22 @@
           <a:noFill/>
         </p:spPr>
         <p:txBody>
-          <a:bodyPr wrap="square" lIns="25400" rIns="25400" tIns="12700" bIns="12700">
-            <a:noAutofit/>
+          <a:bodyPr wrap="square" anchor="t" lIns="0" rIns="0" tIns="0" bIns="0">
+            <a:spAutoFit/>
           </a:bodyPr>
           <a:lstStyle/>
           <a:p>
             <a:pPr algn="l">
               <a:lnSpc>
-                <a:spcPct val="128000"/>
+                <a:spcPct val="115000"/>
               </a:lnSpc>
-              <a:spcAft>
-                <a:spcPts val="400"/>
-              </a:spcAft>
             </a:pPr>
             <a:r>
-              <a:rPr sz="1400" b="0">
-                <a:solidFill>
-                  <a:srgbClr val="9DA9B5"/>
-                </a:solidFill>
-                <a:latin typeface="Arial"/>
+              <a:rPr sz="1050" b="0" i="0">
+                <a:solidFill>
+                  <a:srgbClr val="5C6975"/>
+                </a:solidFill>
+                <a:latin typeface="Consolas"/>
               </a:rPr>
               <a:t>cancer detection — identical</a:t>
             </a:r>
@@ -5814,8 +5583,8 @@
         </p:nvSpPr>
         <p:spPr>
           <a:xfrm>
-            <a:off x="777240" y="4465065"/>
-            <a:ext cx="10607040" cy="346456"/>
+            <a:off x="8229600" y="4114800"/>
+            <a:ext cx="3200400" cy="502920"/>
           </a:xfrm>
           <a:prstGeom prst="rect">
             <a:avLst/>
@@ -5823,45 +5592,24 @@
           <a:noFill/>
         </p:spPr>
         <p:txBody>
-          <a:bodyPr wrap="square" lIns="25400" rIns="25400" tIns="12700" bIns="12700">
-            <a:noAutofit/>
+          <a:bodyPr wrap="square" anchor="t" lIns="0" rIns="0" tIns="0" bIns="0">
+            <a:spAutoFit/>
           </a:bodyPr>
           <a:lstStyle/>
           <a:p>
             <a:pPr algn="l">
               <a:lnSpc>
-                <a:spcPct val="128000"/>
+                <a:spcPct val="100000"/>
               </a:lnSpc>
-              <a:spcAft>
-                <a:spcPts val="400"/>
-              </a:spcAft>
             </a:pPr>
             <a:r>
-              <a:rPr sz="1400" b="0">
-                <a:solidFill>
-                  <a:srgbClr val="9DA9B5"/>
+              <a:rPr sz="1800" b="1" i="0">
+                <a:solidFill>
+                  <a:srgbClr val="ECEFF3"/>
                 </a:solidFill>
                 <a:latin typeface="Arial"/>
               </a:rPr>
-              <a:t>0.871 </a:t>
-            </a:r>
-            <a:r>
-              <a:rPr sz="1400" b="0">
-                <a:solidFill>
-                  <a:srgbClr val="9DA9B5"/>
-                </a:solidFill>
-                <a:latin typeface="Arial"/>
-              </a:rPr>
-              <a:t>vs</a:t>
-            </a:r>
-            <a:r>
-              <a:rPr sz="1400" b="0">
-                <a:solidFill>
-                  <a:srgbClr val="9DA9B5"/>
-                </a:solidFill>
-                <a:latin typeface="Arial"/>
-              </a:rPr>
-              <a:t> 0.919</a:t>
+              <a:t>0.871 vs 0.919</a:t>
             </a:r>
           </a:p>
         </p:txBody>
@@ -5874,8 +5622,8 @@
         </p:nvSpPr>
         <p:spPr>
           <a:xfrm>
-            <a:off x="777240" y="4811521"/>
-            <a:ext cx="10607040" cy="346456"/>
+            <a:off x="8229600" y="4572000"/>
+            <a:ext cx="3200400" cy="548640"/>
           </a:xfrm>
           <a:prstGeom prst="rect">
             <a:avLst/>
@@ -5883,25 +5631,22 @@
           <a:noFill/>
         </p:spPr>
         <p:txBody>
-          <a:bodyPr wrap="square" lIns="25400" rIns="25400" tIns="12700" bIns="12700">
-            <a:noAutofit/>
+          <a:bodyPr wrap="square" anchor="t" lIns="0" rIns="0" tIns="0" bIns="0">
+            <a:spAutoFit/>
           </a:bodyPr>
           <a:lstStyle/>
           <a:p>
             <a:pPr algn="l">
               <a:lnSpc>
-                <a:spcPct val="128000"/>
+                <a:spcPct val="115000"/>
               </a:lnSpc>
-              <a:spcAft>
-                <a:spcPts val="400"/>
-              </a:spcAft>
             </a:pPr>
             <a:r>
-              <a:rPr sz="1400" b="0">
-                <a:solidFill>
-                  <a:srgbClr val="9DA9B5"/>
-                </a:solidFill>
-                <a:latin typeface="Arial"/>
+              <a:rPr sz="1050" b="0" i="0">
+                <a:solidFill>
+                  <a:srgbClr val="5C6975"/>
+                </a:solidFill>
+                <a:latin typeface="Consolas"/>
               </a:rPr>
               <a:t>AUC — with vs without (Fenton, NEJM 2007)</a:t>
             </a:r>
@@ -5943,7 +5688,7 @@
         <p:spPr>
           <a:xfrm>
             <a:off x="0" y="0"/>
-            <a:ext cx="12191695" cy="38100"/>
+            <a:ext cx="5486400" cy="38100"/>
           </a:xfrm>
           <a:prstGeom prst="rect">
             <a:avLst/>
@@ -5986,8 +5731,8 @@
         </p:nvSpPr>
         <p:spPr>
           <a:xfrm>
-            <a:off x="777240" y="411480"/>
-            <a:ext cx="8686800" cy="365760"/>
+            <a:off x="777240" y="502920"/>
+            <a:ext cx="5486400" cy="320040"/>
           </a:xfrm>
           <a:prstGeom prst="rect">
             <a:avLst/>
@@ -5995,21 +5740,18 @@
           <a:noFill/>
         </p:spPr>
         <p:txBody>
-          <a:bodyPr wrap="square" lIns="25400" rIns="25400" tIns="12700" bIns="12700">
-            <a:noAutofit/>
+          <a:bodyPr wrap="square" anchor="t" lIns="0" rIns="0" tIns="0" bIns="0">
+            <a:spAutoFit/>
           </a:bodyPr>
           <a:lstStyle/>
           <a:p>
             <a:pPr algn="l">
               <a:lnSpc>
-                <a:spcPct val="128000"/>
+                <a:spcPct val="100000"/>
               </a:lnSpc>
-              <a:spcAft>
-                <a:spcPts val="400"/>
-              </a:spcAft>
             </a:pPr>
             <a:r>
-              <a:rPr sz="1100" b="1">
+              <a:rPr sz="1100" b="1" i="0">
                 <a:solidFill>
                   <a:srgbClr val="E7AC51"/>
                 </a:solidFill>
@@ -6028,8 +5770,8 @@
         </p:nvSpPr>
         <p:spPr>
           <a:xfrm>
-            <a:off x="777240" y="2560574"/>
-            <a:ext cx="10607040" cy="534416"/>
+            <a:off x="777240" y="960120"/>
+            <a:ext cx="10607040" cy="731520"/>
           </a:xfrm>
           <a:prstGeom prst="rect">
             <a:avLst/>
@@ -6037,21 +5779,18 @@
           <a:noFill/>
         </p:spPr>
         <p:txBody>
-          <a:bodyPr wrap="square" lIns="25400" rIns="25400" tIns="12700" bIns="12700">
-            <a:noAutofit/>
+          <a:bodyPr wrap="square" anchor="t" lIns="0" rIns="0" tIns="0" bIns="0">
+            <a:spAutoFit/>
           </a:bodyPr>
           <a:lstStyle/>
           <a:p>
             <a:pPr algn="l">
               <a:lnSpc>
-                <a:spcPct val="106000"/>
+                <a:spcPct val="100000"/>
               </a:lnSpc>
-              <a:spcAft>
-                <a:spcPts val="400"/>
-              </a:spcAft>
             </a:pPr>
             <a:r>
-              <a:rPr sz="2600" b="0">
+              <a:rPr sz="3000" b="1" i="0">
                 <a:solidFill>
                   <a:srgbClr val="ECEFF3"/>
                 </a:solidFill>
@@ -6064,14 +5803,311 @@
       </p:sp>
       <p:sp>
         <p:nvSpPr>
-          <p:cNvPr id="5" name="TextBox 4"/>
+          <p:cNvPr id="5" name="Rounded Rectangle 4"/>
+          <p:cNvSpPr/>
+          <p:nvPr/>
+        </p:nvSpPr>
+        <p:spPr>
+          <a:xfrm>
+            <a:off x="777240" y="1874519"/>
+            <a:ext cx="10607040" cy="1097280"/>
+          </a:xfrm>
+          <a:prstGeom prst="roundRect">
+            <a:avLst/>
+          </a:prstGeom>
+          <a:solidFill>
+            <a:srgbClr val="1B232D"/>
+          </a:solidFill>
+          <a:ln w="12700">
+            <a:solidFill>
+              <a:srgbClr val="E7AC51"/>
+            </a:solidFill>
+          </a:ln>
+          <a:effectLst/>
+        </p:spPr>
+        <p:style>
+          <a:lnRef idx="1">
+            <a:schemeClr val="accent1"/>
+          </a:lnRef>
+          <a:fillRef idx="3">
+            <a:schemeClr val="accent1"/>
+          </a:fillRef>
+          <a:effectRef idx="2">
+            <a:schemeClr val="accent1"/>
+          </a:effectRef>
+          <a:fontRef idx="minor">
+            <a:schemeClr val="lt1"/>
+          </a:fontRef>
+        </p:style>
+        <p:txBody>
+          <a:bodyPr rtlCol="0" anchor="ctr" wrap="square" lIns="228600" rIns="228600"/>
+          <a:lstStyle/>
+          <a:p>
+            <a:pPr algn="l">
+              <a:lnSpc>
+                <a:spcPct val="100000"/>
+              </a:lnSpc>
+            </a:pPr>
+            <a:r>
+              <a:rPr sz="1300" b="1" i="0">
+                <a:solidFill>
+                  <a:srgbClr val="E7AC51"/>
+                </a:solidFill>
+                <a:latin typeface="Consolas"/>
+              </a:rPr>
+              <a:t>01   </a:t>
+            </a:r>
+            <a:r>
+              <a:rPr sz="1700" b="1" i="0">
+                <a:solidFill>
+                  <a:srgbClr val="ECEFF3"/>
+                </a:solidFill>
+                <a:latin typeface="Arial"/>
+              </a:rPr>
+              <a:t>It flagged only what we can already describe.</a:t>
+            </a:r>
+          </a:p>
+          <a:p>
+            <a:pPr algn="l">
+              <a:lnSpc>
+                <a:spcPct val="122000"/>
+              </a:lnSpc>
+              <a:spcBef>
+                <a:spcPts val="300"/>
+              </a:spcBef>
+            </a:pPr>
+            <a:r>
+              <a:rPr sz="1250" b="1" i="0">
+                <a:solidFill>
+                  <a:srgbClr val="ECEFF3"/>
+                </a:solidFill>
+                <a:latin typeface="Arial"/>
+              </a:rPr>
+              <a:t>Hand-tuned features</a:t>
+            </a:r>
+            <a:r>
+              <a:rPr sz="1250" b="0" i="0">
+                <a:solidFill>
+                  <a:srgbClr val="9DA9B5"/>
+                </a:solidFill>
+                <a:latin typeface="Arial"/>
+              </a:rPr>
+              <a:t> are limited to what we can design — so it added marks, not new information.</a:t>
+            </a:r>
+          </a:p>
+        </p:txBody>
+      </p:sp>
+      <p:sp>
+        <p:nvSpPr>
+          <p:cNvPr id="6" name="Rounded Rectangle 5"/>
+          <p:cNvSpPr/>
+          <p:nvPr/>
+        </p:nvSpPr>
+        <p:spPr>
+          <a:xfrm>
+            <a:off x="777240" y="3118104"/>
+            <a:ext cx="10607040" cy="1097280"/>
+          </a:xfrm>
+          <a:prstGeom prst="roundRect">
+            <a:avLst/>
+          </a:prstGeom>
+          <a:solidFill>
+            <a:srgbClr val="1B232D"/>
+          </a:solidFill>
+          <a:ln w="12700">
+            <a:solidFill>
+              <a:srgbClr val="E7AC51"/>
+            </a:solidFill>
+          </a:ln>
+          <a:effectLst/>
+        </p:spPr>
+        <p:style>
+          <a:lnRef idx="1">
+            <a:schemeClr val="accent1"/>
+          </a:lnRef>
+          <a:fillRef idx="3">
+            <a:schemeClr val="accent1"/>
+          </a:fillRef>
+          <a:effectRef idx="2">
+            <a:schemeClr val="accent1"/>
+          </a:effectRef>
+          <a:fontRef idx="minor">
+            <a:schemeClr val="lt1"/>
+          </a:fontRef>
+        </p:style>
+        <p:txBody>
+          <a:bodyPr rtlCol="0" anchor="ctr" wrap="square" lIns="228600" rIns="228600"/>
+          <a:lstStyle/>
+          <a:p>
+            <a:pPr algn="l">
+              <a:lnSpc>
+                <a:spcPct val="100000"/>
+              </a:lnSpc>
+            </a:pPr>
+            <a:r>
+              <a:rPr sz="1300" b="1" i="0">
+                <a:solidFill>
+                  <a:srgbClr val="E7AC51"/>
+                </a:solidFill>
+                <a:latin typeface="Consolas"/>
+              </a:rPr>
+              <a:t>02   </a:t>
+            </a:r>
+            <a:r>
+              <a:rPr sz="1700" b="1" i="0">
+                <a:solidFill>
+                  <a:srgbClr val="ECEFF3"/>
+                </a:solidFill>
+                <a:latin typeface="Arial"/>
+              </a:rPr>
+              <a:t>Readers learned to ignore it.</a:t>
+            </a:r>
+          </a:p>
+          <a:p>
+            <a:pPr algn="l">
+              <a:lnSpc>
+                <a:spcPct val="122000"/>
+              </a:lnSpc>
+              <a:spcBef>
+                <a:spcPts val="300"/>
+              </a:spcBef>
+            </a:pPr>
+            <a:r>
+              <a:rPr sz="1250" b="1" i="0">
+                <a:solidFill>
+                  <a:srgbClr val="ECEFF3"/>
+                </a:solidFill>
+                <a:latin typeface="Arial"/>
+              </a:rPr>
+              <a:t>70–85% of normal exams</a:t>
+            </a:r>
+            <a:r>
+              <a:rPr sz="1250" b="0" i="0">
+                <a:solidFill>
+                  <a:srgbClr val="9DA9B5"/>
+                </a:solidFill>
+                <a:latin typeface="Arial"/>
+              </a:rPr>
+              <a:t> carried at least one false-positive mark — eroding trust.</a:t>
+            </a:r>
+          </a:p>
+        </p:txBody>
+      </p:sp>
+      <p:sp>
+        <p:nvSpPr>
+          <p:cNvPr id="7" name="Rounded Rectangle 6"/>
+          <p:cNvSpPr/>
+          <p:nvPr/>
+        </p:nvSpPr>
+        <p:spPr>
+          <a:xfrm>
+            <a:off x="777240" y="4361688"/>
+            <a:ext cx="10607040" cy="1097280"/>
+          </a:xfrm>
+          <a:prstGeom prst="roundRect">
+            <a:avLst/>
+          </a:prstGeom>
+          <a:solidFill>
+            <a:srgbClr val="1B232D"/>
+          </a:solidFill>
+          <a:ln w="12700">
+            <a:solidFill>
+              <a:srgbClr val="E7AC51"/>
+            </a:solidFill>
+          </a:ln>
+          <a:effectLst/>
+        </p:spPr>
+        <p:style>
+          <a:lnRef idx="1">
+            <a:schemeClr val="accent1"/>
+          </a:lnRef>
+          <a:fillRef idx="3">
+            <a:schemeClr val="accent1"/>
+          </a:fillRef>
+          <a:effectRef idx="2">
+            <a:schemeClr val="accent1"/>
+          </a:effectRef>
+          <a:fontRef idx="minor">
+            <a:schemeClr val="lt1"/>
+          </a:fontRef>
+        </p:style>
+        <p:txBody>
+          <a:bodyPr rtlCol="0" anchor="ctr" wrap="square" lIns="228600" rIns="228600"/>
+          <a:lstStyle/>
+          <a:p>
+            <a:pPr algn="l">
+              <a:lnSpc>
+                <a:spcPct val="100000"/>
+              </a:lnSpc>
+            </a:pPr>
+            <a:r>
+              <a:rPr sz="1300" b="1" i="0">
+                <a:solidFill>
+                  <a:srgbClr val="E7AC51"/>
+                </a:solidFill>
+                <a:latin typeface="Consolas"/>
+              </a:rPr>
+              <a:t>03   </a:t>
+            </a:r>
+            <a:r>
+              <a:rPr sz="1700" b="1" i="0">
+                <a:solidFill>
+                  <a:srgbClr val="ECEFF3"/>
+                </a:solidFill>
+                <a:latin typeface="Arial"/>
+              </a:rPr>
+              <a:t>It was deployed at scale before it was ever validated.</a:t>
+            </a:r>
+          </a:p>
+          <a:p>
+            <a:pPr algn="l">
+              <a:lnSpc>
+                <a:spcPct val="122000"/>
+              </a:lnSpc>
+              <a:spcBef>
+                <a:spcPts val="300"/>
+              </a:spcBef>
+            </a:pPr>
+            <a:r>
+              <a:rPr sz="1250" b="0" i="0">
+                <a:solidFill>
+                  <a:srgbClr val="9DA9B5"/>
+                </a:solidFill>
+                <a:latin typeface="Arial"/>
+              </a:rPr>
+              <a:t>Reimbursed in 2002 and run on </a:t>
+            </a:r>
+            <a:r>
+              <a:rPr sz="1250" b="1" i="0">
+                <a:solidFill>
+                  <a:srgbClr val="ECEFF3"/>
+                </a:solidFill>
+                <a:latin typeface="Arial"/>
+              </a:rPr>
+              <a:t>~92% of US screening mammograms</a:t>
+            </a:r>
+            <a:r>
+              <a:rPr sz="1250" b="0" i="0">
+                <a:solidFill>
+                  <a:srgbClr val="9DA9B5"/>
+                </a:solidFill>
+                <a:latin typeface="Arial"/>
+              </a:rPr>
+              <a:t> by 2016; the definitive accuracy study didn't arrive until 2015 — and found no benefit.</a:t>
+            </a:r>
+          </a:p>
+        </p:txBody>
+      </p:sp>
+      <p:sp>
+        <p:nvSpPr>
+          <p:cNvPr id="8" name="TextBox 7"/>
           <p:cNvSpPr txBox="1"/>
           <p:nvPr/>
         </p:nvSpPr>
         <p:spPr>
           <a:xfrm>
-            <a:off x="777240" y="3094989"/>
-            <a:ext cx="10607040" cy="574040"/>
+            <a:off x="777240" y="5623560"/>
+            <a:ext cx="10607040" cy="365760"/>
           </a:xfrm>
           <a:prstGeom prst="rect">
             <a:avLst/>
@@ -6079,237 +6115,18 @@
           <a:noFill/>
         </p:spPr>
         <p:txBody>
-          <a:bodyPr wrap="square" lIns="25400" rIns="25400" tIns="12700" bIns="12700">
-            <a:noAutofit/>
+          <a:bodyPr wrap="square" anchor="t" lIns="0" rIns="0" tIns="0" bIns="0">
+            <a:spAutoFit/>
           </a:bodyPr>
           <a:lstStyle/>
           <a:p>
             <a:pPr algn="l">
               <a:lnSpc>
-                <a:spcPct val="128000"/>
+                <a:spcPct val="100000"/>
               </a:lnSpc>
-              <a:spcAft>
-                <a:spcPts val="400"/>
-              </a:spcAft>
             </a:pPr>
             <a:r>
-              <a:rPr sz="1400" b="0">
-                <a:solidFill>
-                  <a:srgbClr val="9DA9B5"/>
-                </a:solidFill>
-                <a:latin typeface="Arial"/>
-              </a:rPr>
-              <a:t>01</a:t>
-            </a:r>
-            <a:r>
-              <a:rPr sz="1400" b="0">
-                <a:solidFill>
-                  <a:srgbClr val="9DA9B5"/>
-                </a:solidFill>
-                <a:latin typeface="Arial"/>
-              </a:rPr>
-              <a:t>It flagged only what we can already describe.</a:t>
-            </a:r>
-            <a:r>
-              <a:rPr sz="1400" b="1">
-                <a:solidFill>
-                  <a:srgbClr val="ECEFF3"/>
-                </a:solidFill>
-                <a:latin typeface="Arial"/>
-              </a:rPr>
-              <a:t>Hand-tuned features</a:t>
-            </a:r>
-            <a:r>
-              <a:rPr sz="1400" b="0">
-                <a:solidFill>
-                  <a:srgbClr val="9DA9B5"/>
-                </a:solidFill>
-                <a:latin typeface="Arial"/>
-              </a:rPr>
-              <a:t> are limited to what we can design — so it added marks, not new information.</a:t>
-            </a:r>
-          </a:p>
-        </p:txBody>
-      </p:sp>
-      <p:sp>
-        <p:nvSpPr>
-          <p:cNvPr id="6" name="TextBox 5"/>
-          <p:cNvSpPr txBox="1"/>
-          <p:nvPr/>
-        </p:nvSpPr>
-        <p:spPr>
-          <a:xfrm>
-            <a:off x="777240" y="3669029"/>
-            <a:ext cx="10607040" cy="346456"/>
-          </a:xfrm>
-          <a:prstGeom prst="rect">
-            <a:avLst/>
-          </a:prstGeom>
-          <a:noFill/>
-        </p:spPr>
-        <p:txBody>
-          <a:bodyPr wrap="square" lIns="25400" rIns="25400" tIns="12700" bIns="12700">
-            <a:noAutofit/>
-          </a:bodyPr>
-          <a:lstStyle/>
-          <a:p>
-            <a:pPr algn="l">
-              <a:lnSpc>
-                <a:spcPct val="128000"/>
-              </a:lnSpc>
-              <a:spcAft>
-                <a:spcPts val="400"/>
-              </a:spcAft>
-            </a:pPr>
-            <a:r>
-              <a:rPr sz="1400" b="0">
-                <a:solidFill>
-                  <a:srgbClr val="9DA9B5"/>
-                </a:solidFill>
-                <a:latin typeface="Arial"/>
-              </a:rPr>
-              <a:t>02</a:t>
-            </a:r>
-            <a:r>
-              <a:rPr sz="1400" b="0">
-                <a:solidFill>
-                  <a:srgbClr val="9DA9B5"/>
-                </a:solidFill>
-                <a:latin typeface="Arial"/>
-              </a:rPr>
-              <a:t>Readers learned to ignore it.</a:t>
-            </a:r>
-            <a:r>
-              <a:rPr sz="1400" b="1">
-                <a:solidFill>
-                  <a:srgbClr val="ECEFF3"/>
-                </a:solidFill>
-                <a:latin typeface="Arial"/>
-              </a:rPr>
-              <a:t>70–85% of normal exams</a:t>
-            </a:r>
-            <a:r>
-              <a:rPr sz="1400" b="0">
-                <a:solidFill>
-                  <a:srgbClr val="9DA9B5"/>
-                </a:solidFill>
-                <a:latin typeface="Arial"/>
-              </a:rPr>
-              <a:t> carried at least one false-positive mark — eroding trust.</a:t>
-            </a:r>
-          </a:p>
-        </p:txBody>
-      </p:sp>
-      <p:sp>
-        <p:nvSpPr>
-          <p:cNvPr id="7" name="TextBox 6"/>
-          <p:cNvSpPr txBox="1"/>
-          <p:nvPr/>
-        </p:nvSpPr>
-        <p:spPr>
-          <a:xfrm>
-            <a:off x="777240" y="4015485"/>
-            <a:ext cx="10607040" cy="574040"/>
-          </a:xfrm>
-          <a:prstGeom prst="rect">
-            <a:avLst/>
-          </a:prstGeom>
-          <a:noFill/>
-        </p:spPr>
-        <p:txBody>
-          <a:bodyPr wrap="square" lIns="25400" rIns="25400" tIns="12700" bIns="12700">
-            <a:noAutofit/>
-          </a:bodyPr>
-          <a:lstStyle/>
-          <a:p>
-            <a:pPr algn="l">
-              <a:lnSpc>
-                <a:spcPct val="128000"/>
-              </a:lnSpc>
-              <a:spcAft>
-                <a:spcPts val="400"/>
-              </a:spcAft>
-            </a:pPr>
-            <a:r>
-              <a:rPr sz="1400" b="0">
-                <a:solidFill>
-                  <a:srgbClr val="9DA9B5"/>
-                </a:solidFill>
-                <a:latin typeface="Arial"/>
-              </a:rPr>
-              <a:t>03</a:t>
-            </a:r>
-            <a:r>
-              <a:rPr sz="1400" b="0">
-                <a:solidFill>
-                  <a:srgbClr val="9DA9B5"/>
-                </a:solidFill>
-                <a:latin typeface="Arial"/>
-              </a:rPr>
-              <a:t>It was deployed at scale before it was ever validated.</a:t>
-            </a:r>
-            <a:r>
-              <a:rPr sz="1400" b="0">
-                <a:solidFill>
-                  <a:srgbClr val="9DA9B5"/>
-                </a:solidFill>
-                <a:latin typeface="Arial"/>
-              </a:rPr>
-              <a:t>Reimbursed in 2002 and run on </a:t>
-            </a:r>
-            <a:r>
-              <a:rPr sz="1400" b="1">
-                <a:solidFill>
-                  <a:srgbClr val="ECEFF3"/>
-                </a:solidFill>
-                <a:latin typeface="Arial"/>
-              </a:rPr>
-              <a:t>~92% of US screening mammograms</a:t>
-            </a:r>
-            <a:r>
-              <a:rPr sz="1400" b="0">
-                <a:solidFill>
-                  <a:srgbClr val="9DA9B5"/>
-                </a:solidFill>
-                <a:latin typeface="Arial"/>
-              </a:rPr>
-              <a:t> by 2016; the definitive accuracy study didn't arrive until 2015 — and found no benefit.</a:t>
-            </a:r>
-          </a:p>
-        </p:txBody>
-      </p:sp>
-      <p:sp>
-        <p:nvSpPr>
-          <p:cNvPr id="8" name="TextBox 7"/>
-          <p:cNvSpPr txBox="1"/>
-          <p:nvPr/>
-        </p:nvSpPr>
-        <p:spPr>
-          <a:xfrm>
-            <a:off x="777240" y="4589525"/>
-            <a:ext cx="10607040" cy="256540"/>
-          </a:xfrm>
-          <a:prstGeom prst="rect">
-            <a:avLst/>
-          </a:prstGeom>
-          <a:noFill/>
-        </p:spPr>
-        <p:txBody>
-          <a:bodyPr wrap="square" lIns="25400" rIns="25400" tIns="12700" bIns="12700">
-            <a:noAutofit/>
-          </a:bodyPr>
-          <a:lstStyle/>
-          <a:p>
-            <a:pPr algn="l">
-              <a:lnSpc>
-                <a:spcPct val="130000"/>
-              </a:lnSpc>
-              <a:spcAft>
-                <a:spcPts val="400"/>
-              </a:spcAft>
-            </a:pPr>
-            <a:r>
-              <a:rPr sz="1000" b="0">
+              <a:rPr sz="950" b="0" i="0">
                 <a:solidFill>
                   <a:srgbClr val="5C6975"/>
                 </a:solidFill>
@@ -6355,7 +6172,7 @@
         <p:spPr>
           <a:xfrm>
             <a:off x="0" y="0"/>
-            <a:ext cx="12191695" cy="38100"/>
+            <a:ext cx="5486400" cy="38100"/>
           </a:xfrm>
           <a:prstGeom prst="rect">
             <a:avLst/>
@@ -6398,8 +6215,8 @@
         </p:nvSpPr>
         <p:spPr>
           <a:xfrm>
-            <a:off x="777240" y="411480"/>
-            <a:ext cx="8686800" cy="365760"/>
+            <a:off x="777240" y="502920"/>
+            <a:ext cx="5486400" cy="320040"/>
           </a:xfrm>
           <a:prstGeom prst="rect">
             <a:avLst/>
@@ -6407,21 +6224,18 @@
           <a:noFill/>
         </p:spPr>
         <p:txBody>
-          <a:bodyPr wrap="square" lIns="25400" rIns="25400" tIns="12700" bIns="12700">
-            <a:noAutofit/>
+          <a:bodyPr wrap="square" anchor="t" lIns="0" rIns="0" tIns="0" bIns="0">
+            <a:spAutoFit/>
           </a:bodyPr>
           <a:lstStyle/>
           <a:p>
             <a:pPr algn="l">
               <a:lnSpc>
-                <a:spcPct val="128000"/>
+                <a:spcPct val="100000"/>
               </a:lnSpc>
-              <a:spcAft>
-                <a:spcPts val="400"/>
-              </a:spcAft>
             </a:pPr>
             <a:r>
-              <a:rPr sz="1100" b="1">
+              <a:rPr sz="1100" b="1" i="0">
                 <a:solidFill>
                   <a:srgbClr val="E7AC51"/>
                 </a:solidFill>
@@ -6440,7 +6254,7 @@
         </p:nvSpPr>
         <p:spPr>
           <a:xfrm>
-            <a:off x="777240" y="1234440"/>
+            <a:off x="777240" y="1371600"/>
             <a:ext cx="10607040" cy="822960"/>
           </a:xfrm>
           <a:prstGeom prst="rect">
@@ -6449,21 +6263,18 @@
           <a:noFill/>
         </p:spPr>
         <p:txBody>
-          <a:bodyPr wrap="square" lIns="25400" rIns="25400" tIns="12700" bIns="12700">
-            <a:noAutofit/>
+          <a:bodyPr wrap="square" anchor="t" lIns="0" rIns="0" tIns="0" bIns="0">
+            <a:spAutoFit/>
           </a:bodyPr>
           <a:lstStyle/>
           <a:p>
             <a:pPr algn="l">
               <a:lnSpc>
-                <a:spcPct val="105000"/>
+                <a:spcPct val="100000"/>
               </a:lnSpc>
-              <a:spcAft>
-                <a:spcPts val="400"/>
-              </a:spcAft>
             </a:pPr>
             <a:r>
-              <a:rPr sz="2600" b="0">
+              <a:rPr sz="3000" b="1" i="0">
                 <a:solidFill>
                   <a:srgbClr val="ECEFF3"/>
                 </a:solidFill>
@@ -6472,7 +6283,7 @@
               <a:t>A paradigm </a:t>
             </a:r>
             <a:r>
-              <a:rPr sz="2600" b="0">
+              <a:rPr sz="3000" b="1" i="0">
                 <a:solidFill>
                   <a:srgbClr val="E7AC51"/>
                 </a:solidFill>
@@ -6502,7 +6313,7 @@
           </a:solidFill>
           <a:ln w="12700">
             <a:solidFill>
-              <a:srgbClr val="2A333E"/>
+              <a:srgbClr val="2A333D"/>
             </a:solidFill>
           </a:ln>
           <a:effectLst/>
@@ -6522,7 +6333,7 @@
           </a:fontRef>
         </p:style>
         <p:txBody>
-          <a:bodyPr rtlCol="0" anchor="t" wrap="square" lIns="274320" rIns="237744" tIns="256032" bIns="182880"/>
+          <a:bodyPr rtlCol="0" anchor="ctr" wrap="square" lIns="274320" rIns="237744" tIns="256032"/>
           <a:lstStyle/>
           <a:p>
             <a:pPr algn="l">
@@ -6531,7 +6342,7 @@
               </a:lnSpc>
             </a:pPr>
             <a:r>
-              <a:rPr sz="1100" b="1">
+              <a:rPr sz="1100" b="1" i="0">
                 <a:solidFill>
                   <a:srgbClr val="5C6975"/>
                 </a:solidFill>
@@ -6550,7 +6361,7 @@
               </a:spcBef>
             </a:pPr>
             <a:r>
-              <a:rPr sz="2400" b="1">
+              <a:rPr sz="2400" b="1" i="0">
                 <a:solidFill>
                   <a:srgbClr val="9DA9B5"/>
                 </a:solidFill>
@@ -6569,7 +6380,7 @@
               </a:spcBef>
             </a:pPr>
             <a:r>
-              <a:rPr sz="1300" b="0">
+              <a:rPr sz="1300" b="0" i="0">
                 <a:solidFill>
                   <a:srgbClr val="9DA9B5"/>
                 </a:solidFill>
@@ -6578,7 +6389,7 @@
               <a:t>We wrote the rules for what cancer looks like. It </a:t>
             </a:r>
             <a:r>
-              <a:rPr sz="1300" b="0">
+              <a:rPr sz="1300" b="0" i="1">
                 <a:solidFill>
                   <a:srgbClr val="9DA9B5"/>
                 </a:solidFill>
@@ -6587,7 +6398,7 @@
               <a:t>pointed</a:t>
             </a:r>
             <a:r>
-              <a:rPr sz="1300" b="0">
+              <a:rPr sz="1300" b="0" i="0">
                 <a:solidFill>
                   <a:srgbClr val="9DA9B5"/>
                 </a:solidFill>
@@ -6637,7 +6448,7 @@
           </a:fontRef>
         </p:style>
         <p:txBody>
-          <a:bodyPr rtlCol="0" anchor="t" wrap="square" lIns="274320" rIns="237744" tIns="256032" bIns="182880"/>
+          <a:bodyPr rtlCol="0" anchor="ctr" wrap="square" lIns="274320" rIns="237744" tIns="256032"/>
           <a:lstStyle/>
           <a:p>
             <a:pPr algn="l">
@@ -6646,7 +6457,7 @@
               </a:lnSpc>
             </a:pPr>
             <a:r>
-              <a:rPr sz="1100" b="1">
+              <a:rPr sz="1100" b="1" i="0">
                 <a:solidFill>
                   <a:srgbClr val="E7AC51"/>
                 </a:solidFill>
@@ -6665,7 +6476,7 @@
               </a:spcBef>
             </a:pPr>
             <a:r>
-              <a:rPr sz="2400" b="1">
+              <a:rPr sz="2400" b="1" i="0">
                 <a:solidFill>
                   <a:srgbClr val="ECEFF3"/>
                 </a:solidFill>
@@ -6684,7 +6495,7 @@
               </a:spcBef>
             </a:pPr>
             <a:r>
-              <a:rPr sz="1300" b="0">
+              <a:rPr sz="1300" b="0" i="0">
                 <a:solidFill>
                   <a:srgbClr val="9DA9B5"/>
                 </a:solidFill>
@@ -6693,16 +6504,16 @@
               <a:t>The model learns the patterns from the images themselves. It can </a:t>
             </a:r>
             <a:r>
-              <a:rPr sz="1300" b="0">
-                <a:solidFill>
-                  <a:srgbClr val="9DA9B5"/>
+              <a:rPr sz="1300" b="0" i="1">
+                <a:solidFill>
+                  <a:srgbClr val="ECEFF3"/>
                 </a:solidFill>
                 <a:latin typeface="Arial"/>
               </a:rPr>
               <a:t>read</a:t>
             </a:r>
             <a:r>
-              <a:rPr sz="1300" b="0">
+              <a:rPr sz="1300" b="0" i="0">
                 <a:solidFill>
                   <a:srgbClr val="9DA9B5"/>
                 </a:solidFill>
@@ -6730,14 +6541,18 @@
           <a:noFill/>
         </p:spPr>
         <p:txBody>
-          <a:bodyPr wrap="none" anchor="ctr">
+          <a:bodyPr wrap="square" anchor="ctr" lIns="0" rIns="0" tIns="0" bIns="0">
             <a:spAutoFit/>
           </a:bodyPr>
           <a:lstStyle/>
           <a:p>
-            <a:pPr algn="ctr"/>
-            <a:r>
-              <a:rPr sz="2800">
+            <a:pPr algn="ctr">
+              <a:lnSpc>
+                <a:spcPct val="100000"/>
+              </a:lnSpc>
+            </a:pPr>
+            <a:r>
+              <a:rPr sz="2800" b="0" i="0">
                 <a:solidFill>
                   <a:srgbClr val="E7AC51"/>
                 </a:solidFill>

</xml_diff>

<commit_message>
Section1 PPTX: add full-bleed gradient + density-contour background motif (captured from HTML) behind every slide
</commit_message>
<xml_diff>
--- a/keynote-iwbi-2026/pptx/sections/IWBI2026_Trivedi_01_CAD.pptx
+++ b/keynote-iwbi-2026/pptx/sections/IWBI2026_Trivedi_01_CAD.pptx
@@ -3942,9 +3942,33 @@
         <p:nvPr/>
       </p:nvGrpSpPr>
       <p:grpSpPr/>
-      <p:sp>
-        <p:nvSpPr>
-          <p:cNvPr id="2" name="Rectangle 1"/>
+      <p:pic>
+        <p:nvPicPr>
+          <p:cNvPr id="2" name="Picture 1" descr="bg_motif.png"/>
+          <p:cNvPicPr>
+            <a:picLocks noChangeAspect="1"/>
+          </p:cNvPicPr>
+          <p:nvPr/>
+        </p:nvPicPr>
+        <p:blipFill>
+          <a:blip r:embed="rId2"/>
+          <a:stretch>
+            <a:fillRect/>
+          </a:stretch>
+        </p:blipFill>
+        <p:spPr>
+          <a:xfrm>
+            <a:off x="0" y="0"/>
+            <a:ext cx="12191695" cy="6858000"/>
+          </a:xfrm>
+          <a:prstGeom prst="rect">
+            <a:avLst/>
+          </a:prstGeom>
+        </p:spPr>
+      </p:pic>
+      <p:sp>
+        <p:nvSpPr>
+          <p:cNvPr id="3" name="Rectangle 2"/>
           <p:cNvSpPr/>
           <p:nvPr/>
         </p:nvSpPr>
@@ -3988,7 +4012,7 @@
       </p:sp>
       <p:sp>
         <p:nvSpPr>
-          <p:cNvPr id="3" name="TextBox 2"/>
+          <p:cNvPr id="4" name="TextBox 3"/>
           <p:cNvSpPr txBox="1"/>
           <p:nvPr/>
         </p:nvSpPr>
@@ -4036,7 +4060,7 @@
       </p:sp>
       <p:sp>
         <p:nvSpPr>
-          <p:cNvPr id="4" name="TextBox 3"/>
+          <p:cNvPr id="5" name="TextBox 4"/>
           <p:cNvSpPr txBox="1"/>
           <p:nvPr/>
         </p:nvSpPr>
@@ -4084,7 +4108,7 @@
       </p:sp>
       <p:sp>
         <p:nvSpPr>
-          <p:cNvPr id="5" name="TextBox 4"/>
+          <p:cNvPr id="6" name="TextBox 5"/>
           <p:cNvSpPr txBox="1"/>
           <p:nvPr/>
         </p:nvSpPr>
@@ -4123,7 +4147,7 @@
       </p:sp>
       <p:sp>
         <p:nvSpPr>
-          <p:cNvPr id="6" name="Rounded Rectangle 5"/>
+          <p:cNvPr id="7" name="Rounded Rectangle 6"/>
           <p:cNvSpPr/>
           <p:nvPr/>
         </p:nvSpPr>
@@ -4169,14 +4193,14 @@
       </p:sp>
       <p:pic>
         <p:nvPicPr>
-          <p:cNvPr id="7" name="Picture 6" descr="img_a5f0143ecc.png"/>
+          <p:cNvPr id="8" name="Picture 7" descr="img_a5f0143ecc.png"/>
           <p:cNvPicPr>
             <a:picLocks noChangeAspect="1"/>
           </p:cNvPicPr>
           <p:nvPr/>
         </p:nvPicPr>
         <p:blipFill>
-          <a:blip r:embed="rId3"/>
+          <a:blip r:embed="rId4"/>
           <a:stretch>
             <a:fillRect/>
           </a:stretch>
@@ -4217,9 +4241,33 @@
         <p:nvPr/>
       </p:nvGrpSpPr>
       <p:grpSpPr/>
-      <p:sp>
-        <p:nvSpPr>
-          <p:cNvPr id="2" name="Rectangle 1"/>
+      <p:pic>
+        <p:nvPicPr>
+          <p:cNvPr id="2" name="Picture 1" descr="bg_motif.png"/>
+          <p:cNvPicPr>
+            <a:picLocks noChangeAspect="1"/>
+          </p:cNvPicPr>
+          <p:nvPr/>
+        </p:nvPicPr>
+        <p:blipFill>
+          <a:blip r:embed="rId2"/>
+          <a:stretch>
+            <a:fillRect/>
+          </a:stretch>
+        </p:blipFill>
+        <p:spPr>
+          <a:xfrm>
+            <a:off x="0" y="0"/>
+            <a:ext cx="12191695" cy="6858000"/>
+          </a:xfrm>
+          <a:prstGeom prst="rect">
+            <a:avLst/>
+          </a:prstGeom>
+        </p:spPr>
+      </p:pic>
+      <p:sp>
+        <p:nvSpPr>
+          <p:cNvPr id="3" name="Rectangle 2"/>
           <p:cNvSpPr/>
           <p:nvPr/>
         </p:nvSpPr>
@@ -4263,7 +4311,7 @@
       </p:sp>
       <p:sp>
         <p:nvSpPr>
-          <p:cNvPr id="3" name="TextBox 2"/>
+          <p:cNvPr id="4" name="TextBox 3"/>
           <p:cNvSpPr txBox="1"/>
           <p:nvPr/>
         </p:nvSpPr>
@@ -4302,7 +4350,7 @@
       </p:sp>
       <p:sp>
         <p:nvSpPr>
-          <p:cNvPr id="4" name="TextBox 3"/>
+          <p:cNvPr id="5" name="TextBox 4"/>
           <p:cNvSpPr txBox="1"/>
           <p:nvPr/>
         </p:nvSpPr>
@@ -4350,14 +4398,14 @@
       </p:sp>
       <p:pic>
         <p:nvPicPr>
-          <p:cNvPr id="5" name="Picture 4" descr="svg_ba5c8d2390.png"/>
+          <p:cNvPr id="6" name="Picture 5" descr="svg_ba5c8d2390.png"/>
           <p:cNvPicPr>
             <a:picLocks noChangeAspect="1"/>
           </p:cNvPicPr>
           <p:nvPr/>
         </p:nvPicPr>
         <p:blipFill>
-          <a:blip r:embed="rId3"/>
+          <a:blip r:embed="rId4"/>
           <a:stretch>
             <a:fillRect/>
           </a:stretch>
@@ -4374,7 +4422,7 @@
       </p:pic>
       <p:sp>
         <p:nvSpPr>
-          <p:cNvPr id="6" name="TextBox 5"/>
+          <p:cNvPr id="7" name="TextBox 6"/>
           <p:cNvSpPr txBox="1"/>
           <p:nvPr/>
         </p:nvSpPr>
@@ -4455,9 +4503,33 @@
         <p:nvPr/>
       </p:nvGrpSpPr>
       <p:grpSpPr/>
-      <p:sp>
-        <p:nvSpPr>
-          <p:cNvPr id="2" name="Rectangle 1"/>
+      <p:pic>
+        <p:nvPicPr>
+          <p:cNvPr id="2" name="Picture 1" descr="bg_motif.png"/>
+          <p:cNvPicPr>
+            <a:picLocks noChangeAspect="1"/>
+          </p:cNvPicPr>
+          <p:nvPr/>
+        </p:nvPicPr>
+        <p:blipFill>
+          <a:blip r:embed="rId2"/>
+          <a:stretch>
+            <a:fillRect/>
+          </a:stretch>
+        </p:blipFill>
+        <p:spPr>
+          <a:xfrm>
+            <a:off x="0" y="0"/>
+            <a:ext cx="12191695" cy="6858000"/>
+          </a:xfrm>
+          <a:prstGeom prst="rect">
+            <a:avLst/>
+          </a:prstGeom>
+        </p:spPr>
+      </p:pic>
+      <p:sp>
+        <p:nvSpPr>
+          <p:cNvPr id="3" name="Rectangle 2"/>
           <p:cNvSpPr/>
           <p:nvPr/>
         </p:nvSpPr>
@@ -4501,7 +4573,7 @@
       </p:sp>
       <p:sp>
         <p:nvSpPr>
-          <p:cNvPr id="3" name="TextBox 2"/>
+          <p:cNvPr id="4" name="TextBox 3"/>
           <p:cNvSpPr txBox="1"/>
           <p:nvPr/>
         </p:nvSpPr>
@@ -4540,7 +4612,7 @@
       </p:sp>
       <p:sp>
         <p:nvSpPr>
-          <p:cNvPr id="4" name="TextBox 3"/>
+          <p:cNvPr id="5" name="TextBox 4"/>
           <p:cNvSpPr txBox="1"/>
           <p:nvPr/>
         </p:nvSpPr>
@@ -4597,7 +4669,7 @@
       </p:sp>
       <p:sp>
         <p:nvSpPr>
-          <p:cNvPr id="5" name="TextBox 4"/>
+          <p:cNvPr id="6" name="TextBox 5"/>
           <p:cNvSpPr txBox="1"/>
           <p:nvPr/>
         </p:nvSpPr>
@@ -4636,7 +4708,7 @@
       </p:sp>
       <p:sp>
         <p:nvSpPr>
-          <p:cNvPr id="6" name="TextBox 5"/>
+          <p:cNvPr id="7" name="TextBox 6"/>
           <p:cNvSpPr txBox="1"/>
           <p:nvPr/>
         </p:nvSpPr>
@@ -4684,7 +4756,7 @@
       </p:sp>
       <p:sp>
         <p:nvSpPr>
-          <p:cNvPr id="7" name="TextBox 6"/>
+          <p:cNvPr id="8" name="TextBox 7"/>
           <p:cNvSpPr txBox="1"/>
           <p:nvPr/>
         </p:nvSpPr>
@@ -4723,7 +4795,7 @@
       </p:sp>
       <p:sp>
         <p:nvSpPr>
-          <p:cNvPr id="8" name="TextBox 7"/>
+          <p:cNvPr id="9" name="TextBox 8"/>
           <p:cNvSpPr txBox="1"/>
           <p:nvPr/>
         </p:nvSpPr>
@@ -4771,7 +4843,7 @@
       </p:sp>
       <p:sp>
         <p:nvSpPr>
-          <p:cNvPr id="9" name="TextBox 8"/>
+          <p:cNvPr id="10" name="TextBox 9"/>
           <p:cNvSpPr txBox="1"/>
           <p:nvPr/>
         </p:nvSpPr>
@@ -4810,14 +4882,14 @@
       </p:sp>
       <p:pic>
         <p:nvPicPr>
-          <p:cNvPr id="10" name="Picture 9" descr="svg_94f6a22e3f.png"/>
+          <p:cNvPr id="11" name="Picture 10" descr="svg_94f6a22e3f.png"/>
           <p:cNvPicPr>
             <a:picLocks noChangeAspect="1"/>
           </p:cNvPicPr>
           <p:nvPr/>
         </p:nvPicPr>
         <p:blipFill>
-          <a:blip r:embed="rId3"/>
+          <a:blip r:embed="rId4"/>
           <a:stretch>
             <a:fillRect/>
           </a:stretch>
@@ -4834,7 +4906,7 @@
       </p:pic>
       <p:sp>
         <p:nvSpPr>
-          <p:cNvPr id="11" name="TextBox 10"/>
+          <p:cNvPr id="12" name="TextBox 11"/>
           <p:cNvSpPr txBox="1"/>
           <p:nvPr/>
         </p:nvSpPr>
@@ -4897,9 +4969,33 @@
         <p:nvPr/>
       </p:nvGrpSpPr>
       <p:grpSpPr/>
-      <p:sp>
-        <p:nvSpPr>
-          <p:cNvPr id="2" name="Rectangle 1"/>
+      <p:pic>
+        <p:nvPicPr>
+          <p:cNvPr id="2" name="Picture 1" descr="bg_motif.png"/>
+          <p:cNvPicPr>
+            <a:picLocks noChangeAspect="1"/>
+          </p:cNvPicPr>
+          <p:nvPr/>
+        </p:nvPicPr>
+        <p:blipFill>
+          <a:blip r:embed="rId2"/>
+          <a:stretch>
+            <a:fillRect/>
+          </a:stretch>
+        </p:blipFill>
+        <p:spPr>
+          <a:xfrm>
+            <a:off x="0" y="0"/>
+            <a:ext cx="12191695" cy="6858000"/>
+          </a:xfrm>
+          <a:prstGeom prst="rect">
+            <a:avLst/>
+          </a:prstGeom>
+        </p:spPr>
+      </p:pic>
+      <p:sp>
+        <p:nvSpPr>
+          <p:cNvPr id="3" name="Rectangle 2"/>
           <p:cNvSpPr/>
           <p:nvPr/>
         </p:nvSpPr>
@@ -4943,7 +5039,7 @@
       </p:sp>
       <p:sp>
         <p:nvSpPr>
-          <p:cNvPr id="3" name="TextBox 2"/>
+          <p:cNvPr id="4" name="TextBox 3"/>
           <p:cNvSpPr txBox="1"/>
           <p:nvPr/>
         </p:nvSpPr>
@@ -4982,7 +5078,7 @@
       </p:sp>
       <p:sp>
         <p:nvSpPr>
-          <p:cNvPr id="4" name="TextBox 3"/>
+          <p:cNvPr id="5" name="TextBox 4"/>
           <p:cNvSpPr txBox="1"/>
           <p:nvPr/>
         </p:nvSpPr>
@@ -5030,7 +5126,7 @@
       </p:sp>
       <p:sp>
         <p:nvSpPr>
-          <p:cNvPr id="5" name="TextBox 4"/>
+          <p:cNvPr id="6" name="TextBox 5"/>
           <p:cNvSpPr txBox="1"/>
           <p:nvPr/>
         </p:nvSpPr>
@@ -5069,7 +5165,7 @@
       </p:sp>
       <p:sp>
         <p:nvSpPr>
-          <p:cNvPr id="6" name="TextBox 5"/>
+          <p:cNvPr id="7" name="TextBox 6"/>
           <p:cNvSpPr txBox="1"/>
           <p:nvPr/>
         </p:nvSpPr>
@@ -5117,7 +5213,7 @@
       </p:sp>
       <p:sp>
         <p:nvSpPr>
-          <p:cNvPr id="7" name="TextBox 6"/>
+          <p:cNvPr id="8" name="TextBox 7"/>
           <p:cNvSpPr txBox="1"/>
           <p:nvPr/>
         </p:nvSpPr>
@@ -5156,7 +5252,7 @@
       </p:sp>
       <p:sp>
         <p:nvSpPr>
-          <p:cNvPr id="8" name="TextBox 7"/>
+          <p:cNvPr id="9" name="TextBox 8"/>
           <p:cNvSpPr txBox="1"/>
           <p:nvPr/>
         </p:nvSpPr>
@@ -5195,7 +5291,7 @@
       </p:sp>
       <p:sp>
         <p:nvSpPr>
-          <p:cNvPr id="9" name="TextBox 8"/>
+          <p:cNvPr id="10" name="TextBox 9"/>
           <p:cNvSpPr txBox="1"/>
           <p:nvPr/>
         </p:nvSpPr>
@@ -5258,9 +5354,33 @@
         <p:nvPr/>
       </p:nvGrpSpPr>
       <p:grpSpPr/>
-      <p:sp>
-        <p:nvSpPr>
-          <p:cNvPr id="2" name="Rectangle 1"/>
+      <p:pic>
+        <p:nvPicPr>
+          <p:cNvPr id="2" name="Picture 1" descr="bg_motif.png"/>
+          <p:cNvPicPr>
+            <a:picLocks noChangeAspect="1"/>
+          </p:cNvPicPr>
+          <p:nvPr/>
+        </p:nvPicPr>
+        <p:blipFill>
+          <a:blip r:embed="rId2"/>
+          <a:stretch>
+            <a:fillRect/>
+          </a:stretch>
+        </p:blipFill>
+        <p:spPr>
+          <a:xfrm>
+            <a:off x="0" y="0"/>
+            <a:ext cx="12191695" cy="6858000"/>
+          </a:xfrm>
+          <a:prstGeom prst="rect">
+            <a:avLst/>
+          </a:prstGeom>
+        </p:spPr>
+      </p:pic>
+      <p:sp>
+        <p:nvSpPr>
+          <p:cNvPr id="3" name="Rectangle 2"/>
           <p:cNvSpPr/>
           <p:nvPr/>
         </p:nvSpPr>
@@ -5304,7 +5424,7 @@
       </p:sp>
       <p:sp>
         <p:nvSpPr>
-          <p:cNvPr id="3" name="TextBox 2"/>
+          <p:cNvPr id="4" name="TextBox 3"/>
           <p:cNvSpPr txBox="1"/>
           <p:nvPr/>
         </p:nvSpPr>
@@ -5343,7 +5463,7 @@
       </p:sp>
       <p:sp>
         <p:nvSpPr>
-          <p:cNvPr id="4" name="TextBox 3"/>
+          <p:cNvPr id="5" name="TextBox 4"/>
           <p:cNvSpPr txBox="1"/>
           <p:nvPr/>
         </p:nvSpPr>
@@ -5382,7 +5502,7 @@
       </p:sp>
       <p:sp>
         <p:nvSpPr>
-          <p:cNvPr id="5" name="TextBox 4"/>
+          <p:cNvPr id="6" name="TextBox 5"/>
           <p:cNvSpPr txBox="1"/>
           <p:nvPr/>
         </p:nvSpPr>
@@ -5421,7 +5541,7 @@
       </p:sp>
       <p:sp>
         <p:nvSpPr>
-          <p:cNvPr id="6" name="TextBox 5"/>
+          <p:cNvPr id="7" name="TextBox 6"/>
           <p:cNvSpPr txBox="1"/>
           <p:nvPr/>
         </p:nvSpPr>
@@ -5460,7 +5580,7 @@
       </p:sp>
       <p:sp>
         <p:nvSpPr>
-          <p:cNvPr id="7" name="TextBox 6"/>
+          <p:cNvPr id="8" name="TextBox 7"/>
           <p:cNvSpPr txBox="1"/>
           <p:nvPr/>
         </p:nvSpPr>
@@ -5499,7 +5619,7 @@
       </p:sp>
       <p:sp>
         <p:nvSpPr>
-          <p:cNvPr id="8" name="TextBox 7"/>
+          <p:cNvPr id="9" name="TextBox 8"/>
           <p:cNvSpPr txBox="1"/>
           <p:nvPr/>
         </p:nvSpPr>
@@ -5538,7 +5658,7 @@
       </p:sp>
       <p:sp>
         <p:nvSpPr>
-          <p:cNvPr id="9" name="TextBox 8"/>
+          <p:cNvPr id="10" name="TextBox 9"/>
           <p:cNvSpPr txBox="1"/>
           <p:nvPr/>
         </p:nvSpPr>
@@ -5577,7 +5697,7 @@
       </p:sp>
       <p:sp>
         <p:nvSpPr>
-          <p:cNvPr id="10" name="TextBox 9"/>
+          <p:cNvPr id="11" name="TextBox 10"/>
           <p:cNvSpPr txBox="1"/>
           <p:nvPr/>
         </p:nvSpPr>
@@ -5616,7 +5736,7 @@
       </p:sp>
       <p:sp>
         <p:nvSpPr>
-          <p:cNvPr id="11" name="TextBox 10"/>
+          <p:cNvPr id="12" name="TextBox 11"/>
           <p:cNvSpPr txBox="1"/>
           <p:nvPr/>
         </p:nvSpPr>
@@ -5679,9 +5799,33 @@
         <p:nvPr/>
       </p:nvGrpSpPr>
       <p:grpSpPr/>
-      <p:sp>
-        <p:nvSpPr>
-          <p:cNvPr id="2" name="Rectangle 1"/>
+      <p:pic>
+        <p:nvPicPr>
+          <p:cNvPr id="2" name="Picture 1" descr="bg_motif.png"/>
+          <p:cNvPicPr>
+            <a:picLocks noChangeAspect="1"/>
+          </p:cNvPicPr>
+          <p:nvPr/>
+        </p:nvPicPr>
+        <p:blipFill>
+          <a:blip r:embed="rId2"/>
+          <a:stretch>
+            <a:fillRect/>
+          </a:stretch>
+        </p:blipFill>
+        <p:spPr>
+          <a:xfrm>
+            <a:off x="0" y="0"/>
+            <a:ext cx="12191695" cy="6858000"/>
+          </a:xfrm>
+          <a:prstGeom prst="rect">
+            <a:avLst/>
+          </a:prstGeom>
+        </p:spPr>
+      </p:pic>
+      <p:sp>
+        <p:nvSpPr>
+          <p:cNvPr id="3" name="Rectangle 2"/>
           <p:cNvSpPr/>
           <p:nvPr/>
         </p:nvSpPr>
@@ -5725,7 +5869,7 @@
       </p:sp>
       <p:sp>
         <p:nvSpPr>
-          <p:cNvPr id="3" name="TextBox 2"/>
+          <p:cNvPr id="4" name="TextBox 3"/>
           <p:cNvSpPr txBox="1"/>
           <p:nvPr/>
         </p:nvSpPr>
@@ -5764,7 +5908,7 @@
       </p:sp>
       <p:sp>
         <p:nvSpPr>
-          <p:cNvPr id="4" name="TextBox 3"/>
+          <p:cNvPr id="5" name="TextBox 4"/>
           <p:cNvSpPr txBox="1"/>
           <p:nvPr/>
         </p:nvSpPr>
@@ -5803,7 +5947,7 @@
       </p:sp>
       <p:sp>
         <p:nvSpPr>
-          <p:cNvPr id="5" name="Rounded Rectangle 4"/>
+          <p:cNvPr id="6" name="Rounded Rectangle 5"/>
           <p:cNvSpPr/>
           <p:nvPr/>
         </p:nvSpPr>
@@ -5899,7 +6043,7 @@
       </p:sp>
       <p:sp>
         <p:nvSpPr>
-          <p:cNvPr id="6" name="Rounded Rectangle 5"/>
+          <p:cNvPr id="7" name="Rounded Rectangle 6"/>
           <p:cNvSpPr/>
           <p:nvPr/>
         </p:nvSpPr>
@@ -5995,7 +6139,7 @@
       </p:sp>
       <p:sp>
         <p:nvSpPr>
-          <p:cNvPr id="7" name="Rounded Rectangle 6"/>
+          <p:cNvPr id="8" name="Rounded Rectangle 7"/>
           <p:cNvSpPr/>
           <p:nvPr/>
         </p:nvSpPr>
@@ -6100,7 +6244,7 @@
       </p:sp>
       <p:sp>
         <p:nvSpPr>
-          <p:cNvPr id="8" name="TextBox 7"/>
+          <p:cNvPr id="9" name="TextBox 8"/>
           <p:cNvSpPr txBox="1"/>
           <p:nvPr/>
         </p:nvSpPr>
@@ -6163,9 +6307,33 @@
         <p:nvPr/>
       </p:nvGrpSpPr>
       <p:grpSpPr/>
-      <p:sp>
-        <p:nvSpPr>
-          <p:cNvPr id="2" name="Rectangle 1"/>
+      <p:pic>
+        <p:nvPicPr>
+          <p:cNvPr id="2" name="Picture 1" descr="bg_motif.png"/>
+          <p:cNvPicPr>
+            <a:picLocks noChangeAspect="1"/>
+          </p:cNvPicPr>
+          <p:nvPr/>
+        </p:nvPicPr>
+        <p:blipFill>
+          <a:blip r:embed="rId2"/>
+          <a:stretch>
+            <a:fillRect/>
+          </a:stretch>
+        </p:blipFill>
+        <p:spPr>
+          <a:xfrm>
+            <a:off x="0" y="0"/>
+            <a:ext cx="12191695" cy="6858000"/>
+          </a:xfrm>
+          <a:prstGeom prst="rect">
+            <a:avLst/>
+          </a:prstGeom>
+        </p:spPr>
+      </p:pic>
+      <p:sp>
+        <p:nvSpPr>
+          <p:cNvPr id="3" name="Rectangle 2"/>
           <p:cNvSpPr/>
           <p:nvPr/>
         </p:nvSpPr>
@@ -6209,7 +6377,7 @@
       </p:sp>
       <p:sp>
         <p:nvSpPr>
-          <p:cNvPr id="3" name="TextBox 2"/>
+          <p:cNvPr id="4" name="TextBox 3"/>
           <p:cNvSpPr txBox="1"/>
           <p:nvPr/>
         </p:nvSpPr>
@@ -6248,7 +6416,7 @@
       </p:sp>
       <p:sp>
         <p:nvSpPr>
-          <p:cNvPr id="4" name="TextBox 3"/>
+          <p:cNvPr id="5" name="TextBox 4"/>
           <p:cNvSpPr txBox="1"/>
           <p:nvPr/>
         </p:nvSpPr>
@@ -6296,7 +6464,7 @@
       </p:sp>
       <p:sp>
         <p:nvSpPr>
-          <p:cNvPr id="5" name="Rounded Rectangle 4"/>
+          <p:cNvPr id="6" name="Rounded Rectangle 5"/>
           <p:cNvSpPr/>
           <p:nvPr/>
         </p:nvSpPr>
@@ -6411,7 +6579,7 @@
       </p:sp>
       <p:sp>
         <p:nvSpPr>
-          <p:cNvPr id="6" name="Rounded Rectangle 5"/>
+          <p:cNvPr id="7" name="Rounded Rectangle 6"/>
           <p:cNvSpPr/>
           <p:nvPr/>
         </p:nvSpPr>
@@ -6526,7 +6694,7 @@
       </p:sp>
       <p:sp>
         <p:nvSpPr>
-          <p:cNvPr id="7" name="TextBox 6"/>
+          <p:cNvPr id="8" name="TextBox 7"/>
           <p:cNvSpPr txBox="1"/>
           <p:nvPr/>
         </p:nvSpPr>

</xml_diff>